<commit_message>
fixed 6 but need activity
</commit_message>
<xml_diff>
--- a/docs/ecostats_lectures/lecture_06/06_01_lecture_powerpoint.pptx
+++ b/docs/ecostats_lectures/lecture_06/06_01_lecture_powerpoint.pptx
@@ -28,6 +28,7 @@
     <p:sldId id="276" r:id="rId22"/>
     <p:sldId id="277" r:id="rId23"/>
     <p:sldId id="278" r:id="rId24"/>
+    <p:sldId id="279" r:id="rId25"/>
   </p:sldIdLst>
   <p:sldSz cx="9144000" cy="5143500" type="screen16x9"/>
   <p:notesSz cx="6858000" cy="9144000"/>
@@ -3434,7 +3435,7 @@
           <a:p>
             <a:pPr lvl="0"/>
             <a:r>
-              <a:rPr/>
+              <a:rPr b="1"/>
               <a:t>α is the rate at which we will reject a true null hypothesis (Type I error rate)</a:t>
             </a:r>
           </a:p>
@@ -4336,7 +4337,11 @@
             </a:r>
             <a:r>
               <a:rPr/>
-              <a:t>: probability of correctly rejecting H₀ when H₁ is true</a:t>
+              <a:t>: </a:t>
+            </a:r>
+            <a:r>
+              <a:rPr b="1"/>
+              <a:t>probability of correctly rejecting H₀ when H₁ is true</a:t>
             </a:r>
           </a:p>
           <a:p>
@@ -4824,7 +4829,7 @@
             </a:pPr>
             <a:r>
               <a:rPr sz="2000"/>
-              <a:t>A researcher concludes that a new fishing regulation increased grayling size, when in fact it had no effect.</a:t>
+              <a:t>A researcher concludes that island mice size is larger, when in fact it is not.</a:t>
             </a:r>
           </a:p>
           <a:p>
@@ -4833,7 +4838,7 @@
             </a:pPr>
             <a:r>
               <a:rPr sz="2000"/>
-              <a:t>A study fails to detect a real decline in grayling population due to warming water, concluding there was no effect.</a:t>
+              <a:t>A study fails to detect a real difference in mouse size on islands when there is and concludes there is no effect.</a:t>
             </a:r>
           </a:p>
           <a:p>
@@ -4842,7 +4847,7 @@
             </a:pPr>
             <a:r>
               <a:rPr sz="2000"/>
-              <a:t>Let’s calculate the power of our t-test to detect a 30 mm difference in length between lakes:</a:t>
+              <a:t>Let’s calculate the power of our t-test to detect a 5 mm difference in mass sampling_sites:</a:t>
             </a:r>
           </a:p>
           <a:p>
@@ -4870,7 +4875,7 @@
             <a:pPr lvl="1"/>
             <a:r>
               <a:rPr sz="2000"/>
-              <a:t>standardized difference between means - here assuming a difference of 30 units (mm)</a:t>
+              <a:t>standardized difference between means - here assuming a difference of 1 units (g)</a:t>
             </a:r>
           </a:p>
           <a:p>
@@ -4879,7 +4884,7 @@
               <a:rPr sz="2000">
                 <a:latin typeface="Courier"/>
               </a:rPr>
-              <a:t>delta = 0.6741298</a:t>
+              <a:t>delta = 0.423</a:t>
             </a:r>
             <a:r>
               <a:rPr sz="2000"/>
@@ -4947,16 +4952,6 @@
               <a:t>(tidyverse)</a:t>
             </a:r>
             <a:br/>
-            <a:br/>
-            <a:r>
-              <a:rPr>
-                <a:solidFill>
-                  <a:srgbClr val="003B4F"/>
-                </a:solidFill>
-                <a:latin typeface="Courier"/>
-              </a:rPr>
-              <a:t>grayling_df &lt;- </a:t>
-            </a:r>
             <a:r>
               <a:rPr>
                 <a:solidFill>
@@ -4964,190 +4959,16 @@
                 </a:solidFill>
                 <a:latin typeface="Courier"/>
               </a:rPr>
-              <a:t>read_csv</a:t>
-            </a:r>
-            <a:r>
-              <a:rPr>
-                <a:solidFill>
-                  <a:srgbClr val="003B4F"/>
-                </a:solidFill>
-                <a:latin typeface="Courier"/>
-              </a:rPr>
-              <a:t>(</a:t>
-            </a:r>
-            <a:r>
-              <a:rPr>
-                <a:solidFill>
-                  <a:srgbClr val="20794D"/>
-                </a:solidFill>
-                <a:latin typeface="Courier"/>
-              </a:rPr>
-              <a:t>"data/gray_I3_I8.csv"</a:t>
-            </a:r>
-            <a:r>
-              <a:rPr>
-                <a:solidFill>
-                  <a:srgbClr val="003B4F"/>
-                </a:solidFill>
-                <a:latin typeface="Courier"/>
-              </a:rPr>
-              <a:t>)</a:t>
-            </a:r>
-            <a:br/>
-            <a:r>
-              <a:rPr>
-                <a:solidFill>
-                  <a:srgbClr val="003B4F"/>
-                </a:solidFill>
-                <a:latin typeface="Courier"/>
-              </a:rPr>
-              <a:t>i3_df &lt;- grayling_df </a:t>
-            </a:r>
-            <a:r>
-              <a:rPr>
-                <a:solidFill>
-                  <a:srgbClr val="5E5E5E"/>
-                </a:solidFill>
-                <a:latin typeface="Courier"/>
-              </a:rPr>
-              <a:t>%&gt;%</a:t>
-            </a:r>
-            <a:r>
-              <a:rPr>
-                <a:solidFill>
-                  <a:srgbClr val="003B4F"/>
-                </a:solidFill>
-                <a:latin typeface="Courier"/>
-              </a:rPr>
-              <a:t> </a:t>
-            </a:r>
-            <a:r>
-              <a:rPr>
-                <a:solidFill>
-                  <a:srgbClr val="4758AB"/>
-                </a:solidFill>
-                <a:latin typeface="Courier"/>
-              </a:rPr>
-              <a:t>filter</a:t>
-            </a:r>
-            <a:r>
-              <a:rPr>
-                <a:solidFill>
-                  <a:srgbClr val="003B4F"/>
-                </a:solidFill>
-                <a:latin typeface="Courier"/>
-              </a:rPr>
-              <a:t>(lake</a:t>
-            </a:r>
-            <a:r>
-              <a:rPr>
-                <a:solidFill>
-                  <a:srgbClr val="5E5E5E"/>
-                </a:solidFill>
-                <a:latin typeface="Courier"/>
-              </a:rPr>
-              <a:t>==</a:t>
-            </a:r>
-            <a:r>
-              <a:rPr>
-                <a:solidFill>
-                  <a:srgbClr val="20794D"/>
-                </a:solidFill>
-                <a:latin typeface="Courier"/>
-              </a:rPr>
-              <a:t>"I3"</a:t>
-            </a:r>
-            <a:r>
-              <a:rPr>
-                <a:solidFill>
-                  <a:srgbClr val="003B4F"/>
-                </a:solidFill>
-                <a:latin typeface="Courier"/>
-              </a:rPr>
-              <a:t>)</a:t>
-            </a:r>
-            <a:br/>
-            <a:r>
-              <a:rPr>
-                <a:solidFill>
-                  <a:srgbClr val="003B4F"/>
-                </a:solidFill>
-                <a:latin typeface="Courier"/>
-              </a:rPr>
-              <a:t>i8_df &lt;- grayling_df </a:t>
-            </a:r>
-            <a:r>
-              <a:rPr>
-                <a:solidFill>
-                  <a:srgbClr val="5E5E5E"/>
-                </a:solidFill>
-                <a:latin typeface="Courier"/>
-              </a:rPr>
-              <a:t>%&gt;%</a:t>
-            </a:r>
-            <a:r>
-              <a:rPr>
-                <a:solidFill>
-                  <a:srgbClr val="003B4F"/>
-                </a:solidFill>
-                <a:latin typeface="Courier"/>
-              </a:rPr>
-              <a:t> </a:t>
-            </a:r>
-            <a:r>
-              <a:rPr>
-                <a:solidFill>
-                  <a:srgbClr val="4758AB"/>
-                </a:solidFill>
-                <a:latin typeface="Courier"/>
-              </a:rPr>
-              <a:t>filter</a:t>
-            </a:r>
-            <a:r>
-              <a:rPr>
-                <a:solidFill>
-                  <a:srgbClr val="003B4F"/>
-                </a:solidFill>
-                <a:latin typeface="Courier"/>
-              </a:rPr>
-              <a:t>(lake</a:t>
-            </a:r>
-            <a:r>
-              <a:rPr>
-                <a:solidFill>
-                  <a:srgbClr val="5E5E5E"/>
-                </a:solidFill>
-                <a:latin typeface="Courier"/>
-              </a:rPr>
-              <a:t>==</a:t>
-            </a:r>
-            <a:r>
-              <a:rPr>
-                <a:solidFill>
-                  <a:srgbClr val="20794D"/>
-                </a:solidFill>
-                <a:latin typeface="Courier"/>
-              </a:rPr>
-              <a:t>"I8"</a:t>
-            </a:r>
-            <a:r>
-              <a:rPr>
-                <a:solidFill>
-                  <a:srgbClr val="003B4F"/>
-                </a:solidFill>
-                <a:latin typeface="Courier"/>
-              </a:rPr>
-              <a:t>)</a:t>
-            </a:r>
-            <a:br/>
-            <a:r>
-              <a:rPr>
-                <a:solidFill>
-                  <a:srgbClr val="5E5E5E"/>
-                </a:solidFill>
-                <a:latin typeface="Courier"/>
-              </a:rPr>
-              <a:t># Calculate power for detecting a 30 mm difference</a:t>
+              <a:t>library</a:t>
+            </a:r>
+            <a:r>
+              <a:rPr>
+                <a:solidFill>
+                  <a:srgbClr val="003B4F"/>
+                </a:solidFill>
+                <a:latin typeface="Courier"/>
+              </a:rPr>
+              <a:t>(readxl)</a:t>
             </a:r>
             <a:br/>
             <a:br/>
@@ -5158,7 +4979,7 @@
                 </a:solidFill>
                 <a:latin typeface="Courier"/>
               </a:rPr>
-              <a:t>n1 &lt;- </a:t>
+              <a:t>m_df &lt;- </a:t>
             </a:r>
             <a:r>
               <a:rPr>
@@ -5167,16 +4988,52 @@
                 </a:solidFill>
                 <a:latin typeface="Courier"/>
               </a:rPr>
-              <a:t>nrow</a:t>
-            </a:r>
-            <a:r>
-              <a:rPr>
-                <a:solidFill>
-                  <a:srgbClr val="003B4F"/>
-                </a:solidFill>
-                <a:latin typeface="Courier"/>
-              </a:rPr>
-              <a:t>(i3_df)</a:t>
+              <a:t>read_csv</a:t>
+            </a:r>
+            <a:r>
+              <a:rPr>
+                <a:solidFill>
+                  <a:srgbClr val="003B4F"/>
+                </a:solidFill>
+                <a:latin typeface="Courier"/>
+              </a:rPr>
+              <a:t>(</a:t>
+            </a:r>
+            <a:r>
+              <a:rPr>
+                <a:solidFill>
+                  <a:srgbClr val="20794D"/>
+                </a:solidFill>
+                <a:latin typeface="Courier"/>
+              </a:rPr>
+              <a:t>"data/mice_weights.csv"</a:t>
+            </a:r>
+            <a:r>
+              <a:rPr>
+                <a:solidFill>
+                  <a:srgbClr val="003B4F"/>
+                </a:solidFill>
+                <a:latin typeface="Courier"/>
+              </a:rPr>
+              <a:t>) </a:t>
+            </a:r>
+            <a:r>
+              <a:rPr>
+                <a:solidFill>
+                  <a:srgbClr val="5E5E5E"/>
+                </a:solidFill>
+                <a:latin typeface="Courier"/>
+              </a:rPr>
+              <a:t>%&gt;%</a:t>
+            </a:r>
+            <a:r>
+              <a:rPr>
+                <a:solidFill>
+                  <a:srgbClr val="003B4F"/>
+                </a:solidFill>
+                <a:latin typeface="Courier"/>
+              </a:rPr>
+              <a:t> </a:t>
             </a:r>
             <a:br/>
             <a:r>
@@ -5186,7 +5043,7 @@
                 </a:solidFill>
                 <a:latin typeface="Courier"/>
               </a:rPr>
-              <a:t>n2 &lt;- </a:t>
+              <a:t>  </a:t>
             </a:r>
             <a:r>
               <a:rPr>
@@ -5195,26 +5052,25 @@
                 </a:solidFill>
                 <a:latin typeface="Courier"/>
               </a:rPr>
-              <a:t>nrow</a:t>
-            </a:r>
-            <a:r>
-              <a:rPr>
-                <a:solidFill>
-                  <a:srgbClr val="003B4F"/>
-                </a:solidFill>
-                <a:latin typeface="Courier"/>
-              </a:rPr>
-              <a:t>(i8_df)</a:t>
-            </a:r>
-            <a:br/>
-            <a:r>
-              <a:rPr>
-                <a:solidFill>
-                  <a:srgbClr val="003B4F"/>
-                </a:solidFill>
-                <a:latin typeface="Courier"/>
-              </a:rPr>
-              <a:t>sd_pooled &lt;- </a:t>
+              <a:t>filter</a:t>
+            </a:r>
+            <a:r>
+              <a:rPr>
+                <a:solidFill>
+                  <a:srgbClr val="003B4F"/>
+                </a:solidFill>
+                <a:latin typeface="Courier"/>
+              </a:rPr>
+              <a:t>(</a:t>
+            </a:r>
+            <a:r>
+              <a:rPr>
+                <a:solidFill>
+                  <a:srgbClr val="5E5E5E"/>
+                </a:solidFill>
+                <a:latin typeface="Courier"/>
+              </a:rPr>
+              <a:t>!</a:t>
             </a:r>
             <a:r>
               <a:rPr>
@@ -5223,273 +5079,29 @@
                 </a:solidFill>
                 <a:latin typeface="Courier"/>
               </a:rPr>
-              <a:t>sqrt</a:t>
-            </a:r>
-            <a:r>
-              <a:rPr>
-                <a:solidFill>
-                  <a:srgbClr val="003B4F"/>
-                </a:solidFill>
-                <a:latin typeface="Courier"/>
-              </a:rPr>
-              <a:t>((</a:t>
-            </a:r>
-            <a:r>
-              <a:rPr>
-                <a:solidFill>
-                  <a:srgbClr val="4758AB"/>
-                </a:solidFill>
-                <a:latin typeface="Courier"/>
-              </a:rPr>
-              <a:t>var</a:t>
-            </a:r>
-            <a:r>
-              <a:rPr>
-                <a:solidFill>
-                  <a:srgbClr val="003B4F"/>
-                </a:solidFill>
-                <a:latin typeface="Courier"/>
-              </a:rPr>
-              <a:t>(i3_df</a:t>
-            </a:r>
-            <a:r>
-              <a:rPr>
-                <a:solidFill>
-                  <a:srgbClr val="5E5E5E"/>
-                </a:solidFill>
-                <a:latin typeface="Courier"/>
-              </a:rPr>
-              <a:t>$</a:t>
-            </a:r>
-            <a:r>
-              <a:rPr>
-                <a:solidFill>
-                  <a:srgbClr val="003B4F"/>
-                </a:solidFill>
-                <a:latin typeface="Courier"/>
-              </a:rPr>
-              <a:t>length_mm) </a:t>
-            </a:r>
-            <a:r>
-              <a:rPr>
-                <a:solidFill>
-                  <a:srgbClr val="5E5E5E"/>
-                </a:solidFill>
-                <a:latin typeface="Courier"/>
-              </a:rPr>
-              <a:t>*</a:t>
-            </a:r>
-            <a:r>
-              <a:rPr>
-                <a:solidFill>
-                  <a:srgbClr val="003B4F"/>
-                </a:solidFill>
-                <a:latin typeface="Courier"/>
-              </a:rPr>
-              <a:t> (n1</a:t>
-            </a:r>
-            <a:r>
-              <a:rPr>
-                <a:solidFill>
-                  <a:srgbClr val="AD0000"/>
-                </a:solidFill>
-                <a:latin typeface="Courier"/>
-              </a:rPr>
-              <a:t>-1</a:t>
-            </a:r>
-            <a:r>
-              <a:rPr>
-                <a:solidFill>
-                  <a:srgbClr val="003B4F"/>
-                </a:solidFill>
-                <a:latin typeface="Courier"/>
-              </a:rPr>
-              <a:t>) </a:t>
-            </a:r>
-            <a:r>
-              <a:rPr>
-                <a:solidFill>
-                  <a:srgbClr val="5E5E5E"/>
-                </a:solidFill>
-                <a:latin typeface="Courier"/>
-              </a:rPr>
-              <a:t>+</a:t>
-            </a:r>
-            <a:r>
-              <a:rPr>
-                <a:solidFill>
-                  <a:srgbClr val="003B4F"/>
-                </a:solidFill>
-                <a:latin typeface="Courier"/>
-              </a:rPr>
-              <a:t> </a:t>
-            </a:r>
-            <a:br/>
-            <a:r>
-              <a:rPr>
-                <a:solidFill>
-                  <a:srgbClr val="003B4F"/>
-                </a:solidFill>
-                <a:latin typeface="Courier"/>
-              </a:rPr>
-              <a:t>                  </a:t>
-            </a:r>
-            <a:r>
-              <a:rPr>
-                <a:solidFill>
-                  <a:srgbClr val="4758AB"/>
-                </a:solidFill>
-                <a:latin typeface="Courier"/>
-              </a:rPr>
-              <a:t>var</a:t>
-            </a:r>
-            <a:r>
-              <a:rPr>
-                <a:solidFill>
-                  <a:srgbClr val="003B4F"/>
-                </a:solidFill>
-                <a:latin typeface="Courier"/>
-              </a:rPr>
-              <a:t>(i8_df</a:t>
-            </a:r>
-            <a:r>
-              <a:rPr>
-                <a:solidFill>
-                  <a:srgbClr val="5E5E5E"/>
-                </a:solidFill>
-                <a:latin typeface="Courier"/>
-              </a:rPr>
-              <a:t>$</a:t>
-            </a:r>
-            <a:r>
-              <a:rPr>
-                <a:solidFill>
-                  <a:srgbClr val="003B4F"/>
-                </a:solidFill>
-                <a:latin typeface="Courier"/>
-              </a:rPr>
-              <a:t>length_mm) </a:t>
-            </a:r>
-            <a:r>
-              <a:rPr>
-                <a:solidFill>
-                  <a:srgbClr val="5E5E5E"/>
-                </a:solidFill>
-                <a:latin typeface="Courier"/>
-              </a:rPr>
-              <a:t>*</a:t>
-            </a:r>
-            <a:r>
-              <a:rPr>
-                <a:solidFill>
-                  <a:srgbClr val="003B4F"/>
-                </a:solidFill>
-                <a:latin typeface="Courier"/>
-              </a:rPr>
-              <a:t> (n2</a:t>
-            </a:r>
-            <a:r>
-              <a:rPr>
-                <a:solidFill>
-                  <a:srgbClr val="AD0000"/>
-                </a:solidFill>
-                <a:latin typeface="Courier"/>
-              </a:rPr>
-              <a:t>-1</a:t>
-            </a:r>
-            <a:r>
-              <a:rPr>
-                <a:solidFill>
-                  <a:srgbClr val="003B4F"/>
-                </a:solidFill>
-                <a:latin typeface="Courier"/>
-              </a:rPr>
-              <a:t>)) </a:t>
-            </a:r>
-            <a:r>
-              <a:rPr>
-                <a:solidFill>
-                  <a:srgbClr val="5E5E5E"/>
-                </a:solidFill>
-                <a:latin typeface="Courier"/>
-              </a:rPr>
-              <a:t>/</a:t>
-            </a:r>
-            <a:r>
-              <a:rPr>
-                <a:solidFill>
-                  <a:srgbClr val="003B4F"/>
-                </a:solidFill>
-                <a:latin typeface="Courier"/>
-              </a:rPr>
-              <a:t> </a:t>
-            </a:r>
-            <a:br/>
-            <a:r>
-              <a:rPr>
-                <a:solidFill>
-                  <a:srgbClr val="003B4F"/>
-                </a:solidFill>
-                <a:latin typeface="Courier"/>
-              </a:rPr>
-              <a:t>                  (n1 </a:t>
-            </a:r>
-            <a:r>
-              <a:rPr>
-                <a:solidFill>
-                  <a:srgbClr val="5E5E5E"/>
-                </a:solidFill>
-                <a:latin typeface="Courier"/>
-              </a:rPr>
-              <a:t>+</a:t>
-            </a:r>
-            <a:r>
-              <a:rPr>
-                <a:solidFill>
-                  <a:srgbClr val="003B4F"/>
-                </a:solidFill>
-                <a:latin typeface="Courier"/>
-              </a:rPr>
-              <a:t> n2 </a:t>
-            </a:r>
-            <a:r>
-              <a:rPr>
-                <a:solidFill>
-                  <a:srgbClr val="5E5E5E"/>
-                </a:solidFill>
-                <a:latin typeface="Courier"/>
-              </a:rPr>
-              <a:t>-</a:t>
-            </a:r>
-            <a:r>
-              <a:rPr>
-                <a:solidFill>
-                  <a:srgbClr val="003B4F"/>
-                </a:solidFill>
-                <a:latin typeface="Courier"/>
-              </a:rPr>
-              <a:t> </a:t>
-            </a:r>
-            <a:r>
-              <a:rPr>
-                <a:solidFill>
-                  <a:srgbClr val="AD0000"/>
-                </a:solidFill>
-                <a:latin typeface="Courier"/>
-              </a:rPr>
-              <a:t>2</a:t>
-            </a:r>
-            <a:r>
-              <a:rPr>
-                <a:solidFill>
-                  <a:srgbClr val="003B4F"/>
-                </a:solidFill>
-                <a:latin typeface="Courier"/>
-              </a:rPr>
-              <a:t>))</a:t>
+              <a:t>is.na</a:t>
+            </a:r>
+            <a:r>
+              <a:rPr>
+                <a:solidFill>
+                  <a:srgbClr val="003B4F"/>
+                </a:solidFill>
+                <a:latin typeface="Courier"/>
+              </a:rPr>
+              <a:t>(mass_g))</a:t>
             </a:r>
             <a:br/>
             <a:br/>
+            <a:br/>
+            <a:r>
+              <a:rPr>
+                <a:solidFill>
+                  <a:srgbClr val="003B4F"/>
+                </a:solidFill>
+                <a:latin typeface="Courier"/>
+              </a:rPr>
+              <a:t>sidney_df &lt;- m_df </a:t>
+            </a:r>
             <a:r>
               <a:rPr>
                 <a:solidFill>
@@ -5497,7 +5109,61 @@
                 </a:solidFill>
                 <a:latin typeface="Courier"/>
               </a:rPr>
-              <a:t># Calculate power</a:t>
+              <a:t>%&gt;%</a:t>
+            </a:r>
+            <a:r>
+              <a:rPr>
+                <a:solidFill>
+                  <a:srgbClr val="003B4F"/>
+                </a:solidFill>
+                <a:latin typeface="Courier"/>
+              </a:rPr>
+              <a:t> </a:t>
+            </a:r>
+            <a:r>
+              <a:rPr>
+                <a:solidFill>
+                  <a:srgbClr val="4758AB"/>
+                </a:solidFill>
+                <a:latin typeface="Courier"/>
+              </a:rPr>
+              <a:t>filter</a:t>
+            </a:r>
+            <a:r>
+              <a:rPr>
+                <a:solidFill>
+                  <a:srgbClr val="003B4F"/>
+                </a:solidFill>
+                <a:latin typeface="Courier"/>
+              </a:rPr>
+              <a:t>(sampling_site</a:t>
+            </a:r>
+            <a:r>
+              <a:rPr>
+                <a:solidFill>
+                  <a:srgbClr val="5E5E5E"/>
+                </a:solidFill>
+                <a:latin typeface="Courier"/>
+              </a:rPr>
+              <a:t>==</a:t>
+            </a:r>
+            <a:r>
+              <a:rPr>
+                <a:solidFill>
+                  <a:srgbClr val="20794D"/>
+                </a:solidFill>
+                <a:latin typeface="Courier"/>
+              </a:rPr>
+              <a:t>"Sidney Island"</a:t>
+            </a:r>
+            <a:r>
+              <a:rPr>
+                <a:solidFill>
+                  <a:srgbClr val="003B4F"/>
+                </a:solidFill>
+                <a:latin typeface="Courier"/>
+              </a:rPr>
+              <a:t>)</a:t>
             </a:r>
             <a:br/>
             <a:r>
@@ -5507,16 +5173,16 @@
                 </a:solidFill>
                 <a:latin typeface="Courier"/>
               </a:rPr>
-              <a:t>effect_size &lt;- </a:t>
-            </a:r>
-            <a:r>
-              <a:rPr>
-                <a:solidFill>
-                  <a:srgbClr val="AD0000"/>
-                </a:solidFill>
-                <a:latin typeface="Courier"/>
-              </a:rPr>
-              <a:t>30</a:t>
+              <a:t>vancouver_df &lt;- m_df </a:t>
+            </a:r>
+            <a:r>
+              <a:rPr>
+                <a:solidFill>
+                  <a:srgbClr val="5E5E5E"/>
+                </a:solidFill>
+                <a:latin typeface="Courier"/>
+              </a:rPr>
+              <a:t>%&gt;%</a:t>
             </a:r>
             <a:r>
               <a:rPr>
@@ -5530,21 +5196,49 @@
             <a:r>
               <a:rPr>
                 <a:solidFill>
+                  <a:srgbClr val="4758AB"/>
+                </a:solidFill>
+                <a:latin typeface="Courier"/>
+              </a:rPr>
+              <a:t>filter</a:t>
+            </a:r>
+            <a:r>
+              <a:rPr>
+                <a:solidFill>
+                  <a:srgbClr val="003B4F"/>
+                </a:solidFill>
+                <a:latin typeface="Courier"/>
+              </a:rPr>
+              <a:t>(sampling_site</a:t>
+            </a:r>
+            <a:r>
+              <a:rPr>
+                <a:solidFill>
                   <a:srgbClr val="5E5E5E"/>
                 </a:solidFill>
                 <a:latin typeface="Courier"/>
               </a:rPr>
-              <a:t>/</a:t>
-            </a:r>
-            <a:r>
-              <a:rPr>
-                <a:solidFill>
-                  <a:srgbClr val="003B4F"/>
-                </a:solidFill>
-                <a:latin typeface="Courier"/>
-              </a:rPr>
-              <a:t> sd_pooled  </a:t>
-            </a:r>
+              <a:t>==</a:t>
+            </a:r>
+            <a:r>
+              <a:rPr>
+                <a:solidFill>
+                  <a:srgbClr val="20794D"/>
+                </a:solidFill>
+                <a:latin typeface="Courier"/>
+              </a:rPr>
+              <a:t>"Vancouver"</a:t>
+            </a:r>
+            <a:r>
+              <a:rPr>
+                <a:solidFill>
+                  <a:srgbClr val="003B4F"/>
+                </a:solidFill>
+                <a:latin typeface="Courier"/>
+              </a:rPr>
+              <a:t>)</a:t>
+            </a:r>
+            <a:br/>
             <a:r>
               <a:rPr>
                 <a:solidFill>
@@ -5552,354 +5246,759 @@
                 </a:solidFill>
                 <a:latin typeface="Courier"/>
               </a:rPr>
-              <a:t># Cohen's d</a:t>
-            </a:r>
-            <a:br/>
-            <a:r>
-              <a:rPr>
-                <a:solidFill>
-                  <a:srgbClr val="003B4F"/>
-                </a:solidFill>
-                <a:latin typeface="Courier"/>
-              </a:rPr>
-              <a:t>df &lt;- n1 </a:t>
-            </a:r>
-            <a:r>
-              <a:rPr>
-                <a:solidFill>
-                  <a:srgbClr val="5E5E5E"/>
-                </a:solidFill>
-                <a:latin typeface="Courier"/>
-              </a:rPr>
-              <a:t>+</a:t>
-            </a:r>
-            <a:r>
-              <a:rPr>
-                <a:solidFill>
-                  <a:srgbClr val="003B4F"/>
-                </a:solidFill>
-                <a:latin typeface="Courier"/>
-              </a:rPr>
-              <a:t> n2 </a:t>
-            </a:r>
-            <a:r>
-              <a:rPr>
-                <a:solidFill>
-                  <a:srgbClr val="5E5E5E"/>
-                </a:solidFill>
-                <a:latin typeface="Courier"/>
-              </a:rPr>
-              <a:t>-</a:t>
-            </a:r>
-            <a:r>
-              <a:rPr>
-                <a:solidFill>
-                  <a:srgbClr val="003B4F"/>
-                </a:solidFill>
-                <a:latin typeface="Courier"/>
-              </a:rPr>
-              <a:t> </a:t>
-            </a:r>
-            <a:r>
-              <a:rPr>
-                <a:solidFill>
-                  <a:srgbClr val="AD0000"/>
-                </a:solidFill>
-                <a:latin typeface="Courier"/>
-              </a:rPr>
-              <a:t>2</a:t>
-            </a:r>
-            <a:br/>
-            <a:r>
-              <a:rPr>
-                <a:solidFill>
-                  <a:srgbClr val="003B4F"/>
-                </a:solidFill>
-                <a:latin typeface="Courier"/>
-              </a:rPr>
-              <a:t>alpha &lt;- </a:t>
-            </a:r>
-            <a:r>
-              <a:rPr>
-                <a:solidFill>
-                  <a:srgbClr val="AD0000"/>
-                </a:solidFill>
-                <a:latin typeface="Courier"/>
-              </a:rPr>
-              <a:t>0.05</a:t>
-            </a:r>
-            <a:br/>
-            <a:r>
-              <a:rPr>
-                <a:solidFill>
-                  <a:srgbClr val="003B4F"/>
-                </a:solidFill>
-                <a:latin typeface="Courier"/>
-              </a:rPr>
-              <a:t>power &lt;- </a:t>
-            </a:r>
-            <a:r>
-              <a:rPr>
-                <a:solidFill>
-                  <a:srgbClr val="4758AB"/>
-                </a:solidFill>
-                <a:latin typeface="Courier"/>
-              </a:rPr>
-              <a:t>power.t.test</a:t>
-            </a:r>
-            <a:r>
-              <a:rPr>
-                <a:solidFill>
-                  <a:srgbClr val="003B4F"/>
-                </a:solidFill>
-                <a:latin typeface="Courier"/>
-              </a:rPr>
-              <a:t>(</a:t>
-            </a:r>
-            <a:r>
-              <a:rPr>
-                <a:solidFill>
-                  <a:srgbClr val="657422"/>
-                </a:solidFill>
-                <a:latin typeface="Courier"/>
-              </a:rPr>
-              <a:t>n =</a:t>
-            </a:r>
-            <a:r>
-              <a:rPr>
-                <a:solidFill>
-                  <a:srgbClr val="003B4F"/>
-                </a:solidFill>
-                <a:latin typeface="Courier"/>
-              </a:rPr>
-              <a:t> </a:t>
-            </a:r>
-            <a:r>
-              <a:rPr>
-                <a:solidFill>
-                  <a:srgbClr val="4758AB"/>
-                </a:solidFill>
-                <a:latin typeface="Courier"/>
-              </a:rPr>
-              <a:t>min</a:t>
-            </a:r>
-            <a:r>
-              <a:rPr>
-                <a:solidFill>
-                  <a:srgbClr val="003B4F"/>
-                </a:solidFill>
-                <a:latin typeface="Courier"/>
-              </a:rPr>
-              <a:t>(n1, n2), </a:t>
-            </a:r>
-            <a:br/>
-            <a:r>
-              <a:rPr>
-                <a:solidFill>
-                  <a:srgbClr val="003B4F"/>
-                </a:solidFill>
-                <a:latin typeface="Courier"/>
-              </a:rPr>
-              <a:t>                     </a:t>
-            </a:r>
-            <a:r>
-              <a:rPr>
-                <a:solidFill>
-                  <a:srgbClr val="657422"/>
-                </a:solidFill>
-                <a:latin typeface="Courier"/>
-              </a:rPr>
-              <a:t>delta =</a:t>
-            </a:r>
-            <a:r>
-              <a:rPr>
-                <a:solidFill>
-                  <a:srgbClr val="003B4F"/>
-                </a:solidFill>
-                <a:latin typeface="Courier"/>
-              </a:rPr>
-              <a:t> effect_size,</a:t>
-            </a:r>
-            <a:br/>
-            <a:r>
-              <a:rPr>
-                <a:solidFill>
-                  <a:srgbClr val="003B4F"/>
-                </a:solidFill>
-                <a:latin typeface="Courier"/>
-              </a:rPr>
-              <a:t>                     </a:t>
-            </a:r>
-            <a:r>
-              <a:rPr>
-                <a:solidFill>
-                  <a:srgbClr val="657422"/>
-                </a:solidFill>
-                <a:latin typeface="Courier"/>
-              </a:rPr>
-              <a:t>sd =</a:t>
-            </a:r>
-            <a:r>
-              <a:rPr>
-                <a:solidFill>
-                  <a:srgbClr val="003B4F"/>
-                </a:solidFill>
-                <a:latin typeface="Courier"/>
-              </a:rPr>
-              <a:t> </a:t>
-            </a:r>
-            <a:r>
-              <a:rPr>
-                <a:solidFill>
-                  <a:srgbClr val="AD0000"/>
-                </a:solidFill>
-                <a:latin typeface="Courier"/>
-              </a:rPr>
-              <a:t>1</a:t>
-            </a:r>
-            <a:r>
-              <a:rPr>
-                <a:solidFill>
-                  <a:srgbClr val="003B4F"/>
-                </a:solidFill>
-                <a:latin typeface="Courier"/>
-              </a:rPr>
-              <a:t>,  </a:t>
-            </a:r>
-            <a:r>
-              <a:rPr>
-                <a:solidFill>
-                  <a:srgbClr val="5E5E5E"/>
-                </a:solidFill>
-                <a:latin typeface="Courier"/>
-              </a:rPr>
-              <a:t># Using standardized effect size</a:t>
-            </a:r>
-            <a:br/>
-            <a:r>
-              <a:rPr>
-                <a:solidFill>
-                  <a:srgbClr val="003B4F"/>
-                </a:solidFill>
-                <a:latin typeface="Courier"/>
-              </a:rPr>
-              <a:t>                     </a:t>
-            </a:r>
-            <a:r>
-              <a:rPr>
-                <a:solidFill>
-                  <a:srgbClr val="657422"/>
-                </a:solidFill>
-                <a:latin typeface="Courier"/>
-              </a:rPr>
-              <a:t>sig.level =</a:t>
-            </a:r>
-            <a:r>
-              <a:rPr>
-                <a:solidFill>
-                  <a:srgbClr val="003B4F"/>
-                </a:solidFill>
-                <a:latin typeface="Courier"/>
-              </a:rPr>
-              <a:t> alpha,</a:t>
-            </a:r>
-            <a:br/>
-            <a:r>
-              <a:rPr>
-                <a:solidFill>
-                  <a:srgbClr val="003B4F"/>
-                </a:solidFill>
-                <a:latin typeface="Courier"/>
-              </a:rPr>
-              <a:t>                     </a:t>
-            </a:r>
-            <a:r>
-              <a:rPr>
-                <a:solidFill>
-                  <a:srgbClr val="657422"/>
-                </a:solidFill>
-                <a:latin typeface="Courier"/>
-              </a:rPr>
-              <a:t>type =</a:t>
-            </a:r>
-            <a:r>
-              <a:rPr>
-                <a:solidFill>
-                  <a:srgbClr val="003B4F"/>
-                </a:solidFill>
-                <a:latin typeface="Courier"/>
-              </a:rPr>
-              <a:t> </a:t>
-            </a:r>
-            <a:r>
-              <a:rPr>
-                <a:solidFill>
-                  <a:srgbClr val="20794D"/>
-                </a:solidFill>
-                <a:latin typeface="Courier"/>
-              </a:rPr>
-              <a:t>"two.sample"</a:t>
-            </a:r>
-            <a:r>
-              <a:rPr>
-                <a:solidFill>
-                  <a:srgbClr val="003B4F"/>
-                </a:solidFill>
-                <a:latin typeface="Courier"/>
-              </a:rPr>
-              <a:t>,</a:t>
-            </a:r>
-            <a:br/>
-            <a:r>
-              <a:rPr>
-                <a:solidFill>
-                  <a:srgbClr val="003B4F"/>
-                </a:solidFill>
-                <a:latin typeface="Courier"/>
-              </a:rPr>
-              <a:t>                     </a:t>
-            </a:r>
-            <a:r>
-              <a:rPr>
-                <a:solidFill>
-                  <a:srgbClr val="657422"/>
-                </a:solidFill>
-                <a:latin typeface="Courier"/>
-              </a:rPr>
-              <a:t>alternative =</a:t>
-            </a:r>
-            <a:r>
-              <a:rPr>
-                <a:solidFill>
-                  <a:srgbClr val="003B4F"/>
-                </a:solidFill>
-                <a:latin typeface="Courier"/>
-              </a:rPr>
-              <a:t> </a:t>
-            </a:r>
-            <a:r>
-              <a:rPr>
-                <a:solidFill>
-                  <a:srgbClr val="20794D"/>
-                </a:solidFill>
-                <a:latin typeface="Courier"/>
-              </a:rPr>
-              <a:t>"two.sided"</a:t>
-            </a:r>
-            <a:r>
-              <a:rPr>
-                <a:solidFill>
-                  <a:srgbClr val="003B4F"/>
-                </a:solidFill>
-                <a:latin typeface="Courier"/>
-              </a:rPr>
-              <a:t>)</a:t>
+              <a:t># Calculate power for detecting a 30 mm difference</a:t>
             </a:r>
             <a:br/>
             <a:br/>
             <a:r>
               <a:rPr>
                 <a:solidFill>
+                  <a:srgbClr val="003B4F"/>
+                </a:solidFill>
+                <a:latin typeface="Courier"/>
+              </a:rPr>
+              <a:t>n1 &lt;- </a:t>
+            </a:r>
+            <a:r>
+              <a:rPr>
+                <a:solidFill>
+                  <a:srgbClr val="4758AB"/>
+                </a:solidFill>
+                <a:latin typeface="Courier"/>
+              </a:rPr>
+              <a:t>nrow</a:t>
+            </a:r>
+            <a:r>
+              <a:rPr>
+                <a:solidFill>
+                  <a:srgbClr val="003B4F"/>
+                </a:solidFill>
+                <a:latin typeface="Courier"/>
+              </a:rPr>
+              <a:t>(sidney_df)</a:t>
+            </a:r>
+            <a:br/>
+            <a:r>
+              <a:rPr>
+                <a:solidFill>
+                  <a:srgbClr val="003B4F"/>
+                </a:solidFill>
+                <a:latin typeface="Courier"/>
+              </a:rPr>
+              <a:t>n2 &lt;- </a:t>
+            </a:r>
+            <a:r>
+              <a:rPr>
+                <a:solidFill>
+                  <a:srgbClr val="4758AB"/>
+                </a:solidFill>
+                <a:latin typeface="Courier"/>
+              </a:rPr>
+              <a:t>nrow</a:t>
+            </a:r>
+            <a:r>
+              <a:rPr>
+                <a:solidFill>
+                  <a:srgbClr val="003B4F"/>
+                </a:solidFill>
+                <a:latin typeface="Courier"/>
+              </a:rPr>
+              <a:t>(vancouver_df)</a:t>
+            </a:r>
+            <a:br/>
+            <a:r>
+              <a:rPr>
+                <a:solidFill>
+                  <a:srgbClr val="003B4F"/>
+                </a:solidFill>
+                <a:latin typeface="Courier"/>
+              </a:rPr>
+              <a:t>sd_pooled &lt;- </a:t>
+            </a:r>
+            <a:r>
+              <a:rPr>
+                <a:solidFill>
+                  <a:srgbClr val="4758AB"/>
+                </a:solidFill>
+                <a:latin typeface="Courier"/>
+              </a:rPr>
+              <a:t>sqrt</a:t>
+            </a:r>
+            <a:r>
+              <a:rPr>
+                <a:solidFill>
+                  <a:srgbClr val="003B4F"/>
+                </a:solidFill>
+                <a:latin typeface="Courier"/>
+              </a:rPr>
+              <a:t>((</a:t>
+            </a:r>
+            <a:r>
+              <a:rPr>
+                <a:solidFill>
+                  <a:srgbClr val="4758AB"/>
+                </a:solidFill>
+                <a:latin typeface="Courier"/>
+              </a:rPr>
+              <a:t>var</a:t>
+            </a:r>
+            <a:r>
+              <a:rPr>
+                <a:solidFill>
+                  <a:srgbClr val="003B4F"/>
+                </a:solidFill>
+                <a:latin typeface="Courier"/>
+              </a:rPr>
+              <a:t>(sidney_df</a:t>
+            </a:r>
+            <a:r>
+              <a:rPr>
+                <a:solidFill>
+                  <a:srgbClr val="5E5E5E"/>
+                </a:solidFill>
+                <a:latin typeface="Courier"/>
+              </a:rPr>
+              <a:t>$</a:t>
+            </a:r>
+            <a:r>
+              <a:rPr>
+                <a:solidFill>
+                  <a:srgbClr val="003B4F"/>
+                </a:solidFill>
+                <a:latin typeface="Courier"/>
+              </a:rPr>
+              <a:t>mass_g) </a:t>
+            </a:r>
+            <a:r>
+              <a:rPr>
+                <a:solidFill>
+                  <a:srgbClr val="5E5E5E"/>
+                </a:solidFill>
+                <a:latin typeface="Courier"/>
+              </a:rPr>
+              <a:t>*</a:t>
+            </a:r>
+            <a:r>
+              <a:rPr>
+                <a:solidFill>
+                  <a:srgbClr val="003B4F"/>
+                </a:solidFill>
+                <a:latin typeface="Courier"/>
+              </a:rPr>
+              <a:t> (n1</a:t>
+            </a:r>
+            <a:r>
+              <a:rPr>
+                <a:solidFill>
+                  <a:srgbClr val="AD0000"/>
+                </a:solidFill>
+                <a:latin typeface="Courier"/>
+              </a:rPr>
+              <a:t>-1</a:t>
+            </a:r>
+            <a:r>
+              <a:rPr>
+                <a:solidFill>
+                  <a:srgbClr val="003B4F"/>
+                </a:solidFill>
+                <a:latin typeface="Courier"/>
+              </a:rPr>
+              <a:t>) </a:t>
+            </a:r>
+            <a:r>
+              <a:rPr>
+                <a:solidFill>
+                  <a:srgbClr val="5E5E5E"/>
+                </a:solidFill>
+                <a:latin typeface="Courier"/>
+              </a:rPr>
+              <a:t>+</a:t>
+            </a:r>
+            <a:r>
+              <a:rPr>
+                <a:solidFill>
+                  <a:srgbClr val="003B4F"/>
+                </a:solidFill>
+                <a:latin typeface="Courier"/>
+              </a:rPr>
+              <a:t> </a:t>
+            </a:r>
+            <a:br/>
+            <a:r>
+              <a:rPr>
+                <a:solidFill>
+                  <a:srgbClr val="003B4F"/>
+                </a:solidFill>
+                <a:latin typeface="Courier"/>
+              </a:rPr>
+              <a:t>                  </a:t>
+            </a:r>
+            <a:r>
+              <a:rPr>
+                <a:solidFill>
+                  <a:srgbClr val="4758AB"/>
+                </a:solidFill>
+                <a:latin typeface="Courier"/>
+              </a:rPr>
+              <a:t>var</a:t>
+            </a:r>
+            <a:r>
+              <a:rPr>
+                <a:solidFill>
+                  <a:srgbClr val="003B4F"/>
+                </a:solidFill>
+                <a:latin typeface="Courier"/>
+              </a:rPr>
+              <a:t>(vancouver_df</a:t>
+            </a:r>
+            <a:r>
+              <a:rPr>
+                <a:solidFill>
+                  <a:srgbClr val="5E5E5E"/>
+                </a:solidFill>
+                <a:latin typeface="Courier"/>
+              </a:rPr>
+              <a:t>$</a:t>
+            </a:r>
+            <a:r>
+              <a:rPr>
+                <a:solidFill>
+                  <a:srgbClr val="003B4F"/>
+                </a:solidFill>
+                <a:latin typeface="Courier"/>
+              </a:rPr>
+              <a:t>mass_g) </a:t>
+            </a:r>
+            <a:r>
+              <a:rPr>
+                <a:solidFill>
+                  <a:srgbClr val="5E5E5E"/>
+                </a:solidFill>
+                <a:latin typeface="Courier"/>
+              </a:rPr>
+              <a:t>*</a:t>
+            </a:r>
+            <a:r>
+              <a:rPr>
+                <a:solidFill>
+                  <a:srgbClr val="003B4F"/>
+                </a:solidFill>
+                <a:latin typeface="Courier"/>
+              </a:rPr>
+              <a:t> (n2</a:t>
+            </a:r>
+            <a:r>
+              <a:rPr>
+                <a:solidFill>
+                  <a:srgbClr val="AD0000"/>
+                </a:solidFill>
+                <a:latin typeface="Courier"/>
+              </a:rPr>
+              <a:t>-1</a:t>
+            </a:r>
+            <a:r>
+              <a:rPr>
+                <a:solidFill>
+                  <a:srgbClr val="003B4F"/>
+                </a:solidFill>
+                <a:latin typeface="Courier"/>
+              </a:rPr>
+              <a:t>)) </a:t>
+            </a:r>
+            <a:r>
+              <a:rPr>
+                <a:solidFill>
+                  <a:srgbClr val="5E5E5E"/>
+                </a:solidFill>
+                <a:latin typeface="Courier"/>
+              </a:rPr>
+              <a:t>/</a:t>
+            </a:r>
+            <a:r>
+              <a:rPr>
+                <a:solidFill>
+                  <a:srgbClr val="003B4F"/>
+                </a:solidFill>
+                <a:latin typeface="Courier"/>
+              </a:rPr>
+              <a:t> </a:t>
+            </a:r>
+            <a:br/>
+            <a:r>
+              <a:rPr>
+                <a:solidFill>
+                  <a:srgbClr val="003B4F"/>
+                </a:solidFill>
+                <a:latin typeface="Courier"/>
+              </a:rPr>
+              <a:t>                  (n1 </a:t>
+            </a:r>
+            <a:r>
+              <a:rPr>
+                <a:solidFill>
+                  <a:srgbClr val="5E5E5E"/>
+                </a:solidFill>
+                <a:latin typeface="Courier"/>
+              </a:rPr>
+              <a:t>+</a:t>
+            </a:r>
+            <a:r>
+              <a:rPr>
+                <a:solidFill>
+                  <a:srgbClr val="003B4F"/>
+                </a:solidFill>
+                <a:latin typeface="Courier"/>
+              </a:rPr>
+              <a:t> n2 </a:t>
+            </a:r>
+            <a:r>
+              <a:rPr>
+                <a:solidFill>
+                  <a:srgbClr val="5E5E5E"/>
+                </a:solidFill>
+                <a:latin typeface="Courier"/>
+              </a:rPr>
+              <a:t>-</a:t>
+            </a:r>
+            <a:r>
+              <a:rPr>
+                <a:solidFill>
+                  <a:srgbClr val="003B4F"/>
+                </a:solidFill>
+                <a:latin typeface="Courier"/>
+              </a:rPr>
+              <a:t> </a:t>
+            </a:r>
+            <a:r>
+              <a:rPr>
+                <a:solidFill>
+                  <a:srgbClr val="AD0000"/>
+                </a:solidFill>
+                <a:latin typeface="Courier"/>
+              </a:rPr>
+              <a:t>2</a:t>
+            </a:r>
+            <a:r>
+              <a:rPr>
+                <a:solidFill>
+                  <a:srgbClr val="003B4F"/>
+                </a:solidFill>
+                <a:latin typeface="Courier"/>
+              </a:rPr>
+              <a:t>))</a:t>
+            </a:r>
+            <a:br/>
+            <a:br/>
+            <a:r>
+              <a:rPr>
+                <a:solidFill>
+                  <a:srgbClr val="5E5E5E"/>
+                </a:solidFill>
+                <a:latin typeface="Courier"/>
+              </a:rPr>
+              <a:t># Calculate power</a:t>
+            </a:r>
+            <a:br/>
+            <a:r>
+              <a:rPr>
+                <a:solidFill>
+                  <a:srgbClr val="003B4F"/>
+                </a:solidFill>
+                <a:latin typeface="Courier"/>
+              </a:rPr>
+              <a:t>effect_size &lt;- </a:t>
+            </a:r>
+            <a:r>
+              <a:rPr>
+                <a:solidFill>
+                  <a:srgbClr val="AD0000"/>
+                </a:solidFill>
+                <a:latin typeface="Courier"/>
+              </a:rPr>
+              <a:t>1</a:t>
+            </a:r>
+            <a:r>
+              <a:rPr>
+                <a:solidFill>
+                  <a:srgbClr val="003B4F"/>
+                </a:solidFill>
+                <a:latin typeface="Courier"/>
+              </a:rPr>
+              <a:t> </a:t>
+            </a:r>
+            <a:r>
+              <a:rPr>
+                <a:solidFill>
+                  <a:srgbClr val="5E5E5E"/>
+                </a:solidFill>
+                <a:latin typeface="Courier"/>
+              </a:rPr>
+              <a:t>/</a:t>
+            </a:r>
+            <a:r>
+              <a:rPr>
+                <a:solidFill>
+                  <a:srgbClr val="003B4F"/>
+                </a:solidFill>
+                <a:latin typeface="Courier"/>
+              </a:rPr>
+              <a:t> sd_pooled  </a:t>
+            </a:r>
+            <a:r>
+              <a:rPr>
+                <a:solidFill>
+                  <a:srgbClr val="5E5E5E"/>
+                </a:solidFill>
+                <a:latin typeface="Courier"/>
+              </a:rPr>
+              <a:t># Cohen's d</a:t>
+            </a:r>
+            <a:br/>
+            <a:r>
+              <a:rPr>
+                <a:solidFill>
+                  <a:srgbClr val="003B4F"/>
+                </a:solidFill>
+                <a:latin typeface="Courier"/>
+              </a:rPr>
+              <a:t>df &lt;- n1 </a:t>
+            </a:r>
+            <a:r>
+              <a:rPr>
+                <a:solidFill>
+                  <a:srgbClr val="5E5E5E"/>
+                </a:solidFill>
+                <a:latin typeface="Courier"/>
+              </a:rPr>
+              <a:t>+</a:t>
+            </a:r>
+            <a:r>
+              <a:rPr>
+                <a:solidFill>
+                  <a:srgbClr val="003B4F"/>
+                </a:solidFill>
+                <a:latin typeface="Courier"/>
+              </a:rPr>
+              <a:t> n2 </a:t>
+            </a:r>
+            <a:r>
+              <a:rPr>
+                <a:solidFill>
+                  <a:srgbClr val="5E5E5E"/>
+                </a:solidFill>
+                <a:latin typeface="Courier"/>
+              </a:rPr>
+              <a:t>-</a:t>
+            </a:r>
+            <a:r>
+              <a:rPr>
+                <a:solidFill>
+                  <a:srgbClr val="003B4F"/>
+                </a:solidFill>
+                <a:latin typeface="Courier"/>
+              </a:rPr>
+              <a:t> </a:t>
+            </a:r>
+            <a:r>
+              <a:rPr>
+                <a:solidFill>
+                  <a:srgbClr val="AD0000"/>
+                </a:solidFill>
+                <a:latin typeface="Courier"/>
+              </a:rPr>
+              <a:t>2</a:t>
+            </a:r>
+            <a:br/>
+            <a:r>
+              <a:rPr>
+                <a:solidFill>
+                  <a:srgbClr val="003B4F"/>
+                </a:solidFill>
+                <a:latin typeface="Courier"/>
+              </a:rPr>
+              <a:t>alpha &lt;- </a:t>
+            </a:r>
+            <a:r>
+              <a:rPr>
+                <a:solidFill>
+                  <a:srgbClr val="AD0000"/>
+                </a:solidFill>
+                <a:latin typeface="Courier"/>
+              </a:rPr>
+              <a:t>0.05</a:t>
+            </a:r>
+            <a:br/>
+            <a:r>
+              <a:rPr>
+                <a:solidFill>
+                  <a:srgbClr val="003B4F"/>
+                </a:solidFill>
+                <a:latin typeface="Courier"/>
+              </a:rPr>
+              <a:t>power &lt;- </a:t>
+            </a:r>
+            <a:r>
+              <a:rPr>
+                <a:solidFill>
+                  <a:srgbClr val="4758AB"/>
+                </a:solidFill>
+                <a:latin typeface="Courier"/>
+              </a:rPr>
+              <a:t>power.t.test</a:t>
+            </a:r>
+            <a:r>
+              <a:rPr>
+                <a:solidFill>
+                  <a:srgbClr val="003B4F"/>
+                </a:solidFill>
+                <a:latin typeface="Courier"/>
+              </a:rPr>
+              <a:t>(</a:t>
+            </a:r>
+            <a:r>
+              <a:rPr>
+                <a:solidFill>
+                  <a:srgbClr val="657422"/>
+                </a:solidFill>
+                <a:latin typeface="Courier"/>
+              </a:rPr>
+              <a:t>n =</a:t>
+            </a:r>
+            <a:r>
+              <a:rPr>
+                <a:solidFill>
+                  <a:srgbClr val="003B4F"/>
+                </a:solidFill>
+                <a:latin typeface="Courier"/>
+              </a:rPr>
+              <a:t> </a:t>
+            </a:r>
+            <a:r>
+              <a:rPr>
+                <a:solidFill>
+                  <a:srgbClr val="4758AB"/>
+                </a:solidFill>
+                <a:latin typeface="Courier"/>
+              </a:rPr>
+              <a:t>min</a:t>
+            </a:r>
+            <a:r>
+              <a:rPr>
+                <a:solidFill>
+                  <a:srgbClr val="003B4F"/>
+                </a:solidFill>
+                <a:latin typeface="Courier"/>
+              </a:rPr>
+              <a:t>(n1, n2), </a:t>
+            </a:r>
+            <a:br/>
+            <a:r>
+              <a:rPr>
+                <a:solidFill>
+                  <a:srgbClr val="003B4F"/>
+                </a:solidFill>
+                <a:latin typeface="Courier"/>
+              </a:rPr>
+              <a:t>                     </a:t>
+            </a:r>
+            <a:r>
+              <a:rPr>
+                <a:solidFill>
+                  <a:srgbClr val="657422"/>
+                </a:solidFill>
+                <a:latin typeface="Courier"/>
+              </a:rPr>
+              <a:t>delta =</a:t>
+            </a:r>
+            <a:r>
+              <a:rPr>
+                <a:solidFill>
+                  <a:srgbClr val="003B4F"/>
+                </a:solidFill>
+                <a:latin typeface="Courier"/>
+              </a:rPr>
+              <a:t> effect_size,</a:t>
+            </a:r>
+            <a:br/>
+            <a:r>
+              <a:rPr>
+                <a:solidFill>
+                  <a:srgbClr val="003B4F"/>
+                </a:solidFill>
+                <a:latin typeface="Courier"/>
+              </a:rPr>
+              <a:t>                     </a:t>
+            </a:r>
+            <a:r>
+              <a:rPr>
+                <a:solidFill>
+                  <a:srgbClr val="657422"/>
+                </a:solidFill>
+                <a:latin typeface="Courier"/>
+              </a:rPr>
+              <a:t>sd =</a:t>
+            </a:r>
+            <a:r>
+              <a:rPr>
+                <a:solidFill>
+                  <a:srgbClr val="003B4F"/>
+                </a:solidFill>
+                <a:latin typeface="Courier"/>
+              </a:rPr>
+              <a:t> </a:t>
+            </a:r>
+            <a:r>
+              <a:rPr>
+                <a:solidFill>
+                  <a:srgbClr val="AD0000"/>
+                </a:solidFill>
+                <a:latin typeface="Courier"/>
+              </a:rPr>
+              <a:t>1</a:t>
+            </a:r>
+            <a:r>
+              <a:rPr>
+                <a:solidFill>
+                  <a:srgbClr val="003B4F"/>
+                </a:solidFill>
+                <a:latin typeface="Courier"/>
+              </a:rPr>
+              <a:t>,  </a:t>
+            </a:r>
+            <a:r>
+              <a:rPr>
+                <a:solidFill>
+                  <a:srgbClr val="5E5E5E"/>
+                </a:solidFill>
+                <a:latin typeface="Courier"/>
+              </a:rPr>
+              <a:t># Using standardized effect size</a:t>
+            </a:r>
+            <a:br/>
+            <a:r>
+              <a:rPr>
+                <a:solidFill>
+                  <a:srgbClr val="003B4F"/>
+                </a:solidFill>
+                <a:latin typeface="Courier"/>
+              </a:rPr>
+              <a:t>                     </a:t>
+            </a:r>
+            <a:r>
+              <a:rPr>
+                <a:solidFill>
+                  <a:srgbClr val="657422"/>
+                </a:solidFill>
+                <a:latin typeface="Courier"/>
+              </a:rPr>
+              <a:t>sig.level =</a:t>
+            </a:r>
+            <a:r>
+              <a:rPr>
+                <a:solidFill>
+                  <a:srgbClr val="003B4F"/>
+                </a:solidFill>
+                <a:latin typeface="Courier"/>
+              </a:rPr>
+              <a:t> alpha,</a:t>
+            </a:r>
+            <a:br/>
+            <a:r>
+              <a:rPr>
+                <a:solidFill>
+                  <a:srgbClr val="003B4F"/>
+                </a:solidFill>
+                <a:latin typeface="Courier"/>
+              </a:rPr>
+              <a:t>                     </a:t>
+            </a:r>
+            <a:r>
+              <a:rPr>
+                <a:solidFill>
+                  <a:srgbClr val="657422"/>
+                </a:solidFill>
+                <a:latin typeface="Courier"/>
+              </a:rPr>
+              <a:t>type =</a:t>
+            </a:r>
+            <a:r>
+              <a:rPr>
+                <a:solidFill>
+                  <a:srgbClr val="003B4F"/>
+                </a:solidFill>
+                <a:latin typeface="Courier"/>
+              </a:rPr>
+              <a:t> </a:t>
+            </a:r>
+            <a:r>
+              <a:rPr>
+                <a:solidFill>
+                  <a:srgbClr val="20794D"/>
+                </a:solidFill>
+                <a:latin typeface="Courier"/>
+              </a:rPr>
+              <a:t>"two.sample"</a:t>
+            </a:r>
+            <a:r>
+              <a:rPr>
+                <a:solidFill>
+                  <a:srgbClr val="003B4F"/>
+                </a:solidFill>
+                <a:latin typeface="Courier"/>
+              </a:rPr>
+              <a:t>,</a:t>
+            </a:r>
+            <a:br/>
+            <a:r>
+              <a:rPr>
+                <a:solidFill>
+                  <a:srgbClr val="003B4F"/>
+                </a:solidFill>
+                <a:latin typeface="Courier"/>
+              </a:rPr>
+              <a:t>                     </a:t>
+            </a:r>
+            <a:r>
+              <a:rPr>
+                <a:solidFill>
+                  <a:srgbClr val="657422"/>
+                </a:solidFill>
+                <a:latin typeface="Courier"/>
+              </a:rPr>
+              <a:t>alternative =</a:t>
+            </a:r>
+            <a:r>
+              <a:rPr>
+                <a:solidFill>
+                  <a:srgbClr val="003B4F"/>
+                </a:solidFill>
+                <a:latin typeface="Courier"/>
+              </a:rPr>
+              <a:t> </a:t>
+            </a:r>
+            <a:r>
+              <a:rPr>
+                <a:solidFill>
+                  <a:srgbClr val="20794D"/>
+                </a:solidFill>
+                <a:latin typeface="Courier"/>
+              </a:rPr>
+              <a:t>"two.sided"</a:t>
+            </a:r>
+            <a:r>
+              <a:rPr>
+                <a:solidFill>
+                  <a:srgbClr val="003B4F"/>
+                </a:solidFill>
+                <a:latin typeface="Courier"/>
+              </a:rPr>
+              <a:t>)</a:t>
+            </a:r>
+            <a:br/>
+            <a:br/>
+            <a:r>
+              <a:rPr>
+                <a:solidFill>
                   <a:srgbClr val="5E5E5E"/>
                 </a:solidFill>
                 <a:latin typeface="Courier"/>
@@ -5927,11 +6026,11 @@
               </a:rPr>
               <a:t>
      Two-sample t test power calculation 
-              n = 66
-          delta = 0.6741298
+              n = 28
+          delta = 0.4231154
              sd = 1
       sig.level = 0.05
-          power = 0.9702076
+          power = 0.3427604
     alternative = two.sided
 NOTE: n is number in *each* group</a:t>
             </a:r>
@@ -5985,7 +6084,7 @@
             </a:pPr>
             <a:r>
               <a:rPr/>
-              <a:t>What is Power</a:t>
+              <a:t>What if we calculated power for the pine needles you measured?</a:t>
             </a:r>
           </a:p>
         </p:txBody>
@@ -6005,65 +6104,1722 @@
           <a:bodyPr/>
           <a:lstStyle/>
           <a:p>
-            <a:pPr lvl="0" indent="0" marL="0">
+            <a:pPr lvl="0" indent="0">
               <a:buNone/>
             </a:pPr>
             <a:r>
-              <a:rPr/>
-              <a:t>Statistical power represents the probability of detecting a true effect (rejecting the null hypothesis when it is false). In this case, with a power of 97%, there’s a 97% chance of detecting a true difference of 30 units between the means of the two groups if such a difference actually exists.</a:t>
-            </a:r>
-          </a:p>
-          <a:p>
-            <a:pPr lvl="0" indent="0" marL="0">
+              <a:rPr>
+                <a:solidFill>
+                  <a:srgbClr val="003B4F"/>
+                </a:solidFill>
+                <a:latin typeface="Courier"/>
+              </a:rPr>
+              <a:t>pine_switch_df &lt;- </a:t>
+            </a:r>
+            <a:r>
+              <a:rPr>
+                <a:solidFill>
+                  <a:srgbClr val="4758AB"/>
+                </a:solidFill>
+                <a:latin typeface="Courier"/>
+              </a:rPr>
+              <a:t>read_excel</a:t>
+            </a:r>
+            <a:r>
+              <a:rPr>
+                <a:solidFill>
+                  <a:srgbClr val="003B4F"/>
+                </a:solidFill>
+                <a:latin typeface="Courier"/>
+              </a:rPr>
+              <a:t>(</a:t>
+            </a:r>
+            <a:r>
+              <a:rPr>
+                <a:solidFill>
+                  <a:srgbClr val="20794D"/>
+                </a:solidFill>
+                <a:latin typeface="Courier"/>
+              </a:rPr>
+              <a:t>"data/class_pine needle length switched.xlsx"</a:t>
+            </a:r>
+            <a:r>
+              <a:rPr>
+                <a:solidFill>
+                  <a:srgbClr val="003B4F"/>
+                </a:solidFill>
+                <a:latin typeface="Courier"/>
+              </a:rPr>
+              <a:t>)</a:t>
+            </a:r>
+            <a:br/>
+            <a:r>
+              <a:rPr>
+                <a:solidFill>
+                  <a:srgbClr val="003B4F"/>
+                </a:solidFill>
+                <a:latin typeface="Courier"/>
+              </a:rPr>
+              <a:t>ps_df &lt;- pine_switch_df </a:t>
+            </a:r>
+            <a:r>
+              <a:rPr>
+                <a:solidFill>
+                  <a:srgbClr val="5E5E5E"/>
+                </a:solidFill>
+                <a:latin typeface="Courier"/>
+              </a:rPr>
+              <a:t>%&gt;%</a:t>
+            </a:r>
+            <a:r>
+              <a:rPr>
+                <a:solidFill>
+                  <a:srgbClr val="003B4F"/>
+                </a:solidFill>
+                <a:latin typeface="Courier"/>
+              </a:rPr>
+              <a:t> </a:t>
+            </a:r>
+            <a:br/>
+            <a:r>
+              <a:rPr>
+                <a:solidFill>
+                  <a:srgbClr val="003B4F"/>
+                </a:solidFill>
+                <a:latin typeface="Courier"/>
+              </a:rPr>
+              <a:t>  </a:t>
+            </a:r>
+            <a:r>
+              <a:rPr>
+                <a:solidFill>
+                  <a:srgbClr val="4758AB"/>
+                </a:solidFill>
+                <a:latin typeface="Courier"/>
+              </a:rPr>
+              <a:t>group_by</a:t>
+            </a:r>
+            <a:r>
+              <a:rPr>
+                <a:solidFill>
+                  <a:srgbClr val="003B4F"/>
+                </a:solidFill>
+                <a:latin typeface="Courier"/>
+              </a:rPr>
+              <a:t>(group, tree_no, tree_char, side) </a:t>
+            </a:r>
+            <a:r>
+              <a:rPr>
+                <a:solidFill>
+                  <a:srgbClr val="5E5E5E"/>
+                </a:solidFill>
+                <a:latin typeface="Courier"/>
+              </a:rPr>
+              <a:t>%&gt;%</a:t>
+            </a:r>
+            <a:r>
+              <a:rPr>
+                <a:solidFill>
+                  <a:srgbClr val="003B4F"/>
+                </a:solidFill>
+                <a:latin typeface="Courier"/>
+              </a:rPr>
+              <a:t> </a:t>
+            </a:r>
+            <a:br/>
+            <a:r>
+              <a:rPr>
+                <a:solidFill>
+                  <a:srgbClr val="003B4F"/>
+                </a:solidFill>
+                <a:latin typeface="Courier"/>
+              </a:rPr>
+              <a:t>  </a:t>
+            </a:r>
+            <a:r>
+              <a:rPr>
+                <a:solidFill>
+                  <a:srgbClr val="4758AB"/>
+                </a:solidFill>
+                <a:latin typeface="Courier"/>
+              </a:rPr>
+              <a:t>summarise</a:t>
+            </a:r>
+            <a:r>
+              <a:rPr>
+                <a:solidFill>
+                  <a:srgbClr val="003B4F"/>
+                </a:solidFill>
+                <a:latin typeface="Courier"/>
+              </a:rPr>
+              <a:t>(</a:t>
+            </a:r>
+            <a:r>
+              <a:rPr>
+                <a:solidFill>
+                  <a:srgbClr val="657422"/>
+                </a:solidFill>
+                <a:latin typeface="Courier"/>
+              </a:rPr>
+              <a:t>length_mm =</a:t>
+            </a:r>
+            <a:r>
+              <a:rPr>
+                <a:solidFill>
+                  <a:srgbClr val="003B4F"/>
+                </a:solidFill>
+                <a:latin typeface="Courier"/>
+              </a:rPr>
+              <a:t> </a:t>
+            </a:r>
+            <a:r>
+              <a:rPr>
+                <a:solidFill>
+                  <a:srgbClr val="4758AB"/>
+                </a:solidFill>
+                <a:latin typeface="Courier"/>
+              </a:rPr>
+              <a:t>mean</a:t>
+            </a:r>
+            <a:r>
+              <a:rPr>
+                <a:solidFill>
+                  <a:srgbClr val="003B4F"/>
+                </a:solidFill>
+                <a:latin typeface="Courier"/>
+              </a:rPr>
+              <a:t>(length_mm, </a:t>
+            </a:r>
+            <a:r>
+              <a:rPr>
+                <a:solidFill>
+                  <a:srgbClr val="657422"/>
+                </a:solidFill>
+                <a:latin typeface="Courier"/>
+              </a:rPr>
+              <a:t>na.rm=</a:t>
+            </a:r>
+            <a:r>
+              <a:rPr>
+                <a:solidFill>
+                  <a:srgbClr val="8F5902"/>
+                </a:solidFill>
+                <a:latin typeface="Courier"/>
+              </a:rPr>
+              <a:t>TRUE</a:t>
+            </a:r>
+            <a:r>
+              <a:rPr>
+                <a:solidFill>
+                  <a:srgbClr val="003B4F"/>
+                </a:solidFill>
+                <a:latin typeface="Courier"/>
+              </a:rPr>
+              <a:t>))</a:t>
+            </a:r>
+            <a:br/>
+            <a:br/>
+            <a:r>
+              <a:rPr>
+                <a:solidFill>
+                  <a:srgbClr val="003B4F"/>
+                </a:solidFill>
+                <a:latin typeface="Courier"/>
+              </a:rPr>
+              <a:t>ps_shady_df &lt;- ps_df </a:t>
+            </a:r>
+            <a:r>
+              <a:rPr>
+                <a:solidFill>
+                  <a:srgbClr val="5E5E5E"/>
+                </a:solidFill>
+                <a:latin typeface="Courier"/>
+              </a:rPr>
+              <a:t>%&gt;%</a:t>
+            </a:r>
+            <a:r>
+              <a:rPr>
+                <a:solidFill>
+                  <a:srgbClr val="003B4F"/>
+                </a:solidFill>
+                <a:latin typeface="Courier"/>
+              </a:rPr>
+              <a:t> </a:t>
+            </a:r>
+            <a:br/>
+            <a:r>
+              <a:rPr>
+                <a:solidFill>
+                  <a:srgbClr val="003B4F"/>
+                </a:solidFill>
+                <a:latin typeface="Courier"/>
+              </a:rPr>
+              <a:t>  </a:t>
+            </a:r>
+            <a:r>
+              <a:rPr>
+                <a:solidFill>
+                  <a:srgbClr val="4758AB"/>
+                </a:solidFill>
+                <a:latin typeface="Courier"/>
+              </a:rPr>
+              <a:t>filter</a:t>
+            </a:r>
+            <a:r>
+              <a:rPr>
+                <a:solidFill>
+                  <a:srgbClr val="003B4F"/>
+                </a:solidFill>
+                <a:latin typeface="Courier"/>
+              </a:rPr>
+              <a:t>(side </a:t>
+            </a:r>
+            <a:r>
+              <a:rPr>
+                <a:solidFill>
+                  <a:srgbClr val="5E5E5E"/>
+                </a:solidFill>
+                <a:latin typeface="Courier"/>
+              </a:rPr>
+              <a:t>==</a:t>
+            </a:r>
+            <a:r>
+              <a:rPr>
+                <a:solidFill>
+                  <a:srgbClr val="003B4F"/>
+                </a:solidFill>
+                <a:latin typeface="Courier"/>
+              </a:rPr>
+              <a:t> </a:t>
+            </a:r>
+            <a:r>
+              <a:rPr>
+                <a:solidFill>
+                  <a:srgbClr val="20794D"/>
+                </a:solidFill>
+                <a:latin typeface="Courier"/>
+              </a:rPr>
+              <a:t>"shady"</a:t>
+            </a:r>
+            <a:r>
+              <a:rPr>
+                <a:solidFill>
+                  <a:srgbClr val="003B4F"/>
+                </a:solidFill>
+                <a:latin typeface="Courier"/>
+              </a:rPr>
+              <a:t>)</a:t>
+            </a:r>
+            <a:br/>
+            <a:br/>
+            <a:r>
+              <a:rPr>
+                <a:solidFill>
+                  <a:srgbClr val="003B4F"/>
+                </a:solidFill>
+                <a:latin typeface="Courier"/>
+              </a:rPr>
+              <a:t>ps_sunny_df &lt;- ps_df </a:t>
+            </a:r>
+            <a:r>
+              <a:rPr>
+                <a:solidFill>
+                  <a:srgbClr val="5E5E5E"/>
+                </a:solidFill>
+                <a:latin typeface="Courier"/>
+              </a:rPr>
+              <a:t>%&gt;%</a:t>
+            </a:r>
+            <a:r>
+              <a:rPr>
+                <a:solidFill>
+                  <a:srgbClr val="003B4F"/>
+                </a:solidFill>
+                <a:latin typeface="Courier"/>
+              </a:rPr>
+              <a:t> </a:t>
+            </a:r>
+            <a:br/>
+            <a:r>
+              <a:rPr>
+                <a:solidFill>
+                  <a:srgbClr val="003B4F"/>
+                </a:solidFill>
+                <a:latin typeface="Courier"/>
+              </a:rPr>
+              <a:t>  </a:t>
+            </a:r>
+            <a:r>
+              <a:rPr>
+                <a:solidFill>
+                  <a:srgbClr val="4758AB"/>
+                </a:solidFill>
+                <a:latin typeface="Courier"/>
+              </a:rPr>
+              <a:t>filter</a:t>
+            </a:r>
+            <a:r>
+              <a:rPr>
+                <a:solidFill>
+                  <a:srgbClr val="003B4F"/>
+                </a:solidFill>
+                <a:latin typeface="Courier"/>
+              </a:rPr>
+              <a:t>(side </a:t>
+            </a:r>
+            <a:r>
+              <a:rPr>
+                <a:solidFill>
+                  <a:srgbClr val="5E5E5E"/>
+                </a:solidFill>
+                <a:latin typeface="Courier"/>
+              </a:rPr>
+              <a:t>==</a:t>
+            </a:r>
+            <a:r>
+              <a:rPr>
+                <a:solidFill>
+                  <a:srgbClr val="003B4F"/>
+                </a:solidFill>
+                <a:latin typeface="Courier"/>
+              </a:rPr>
+              <a:t> </a:t>
+            </a:r>
+            <a:r>
+              <a:rPr>
+                <a:solidFill>
+                  <a:srgbClr val="20794D"/>
+                </a:solidFill>
+                <a:latin typeface="Courier"/>
+              </a:rPr>
+              <a:t>"sunny"</a:t>
+            </a:r>
+            <a:r>
+              <a:rPr>
+                <a:solidFill>
+                  <a:srgbClr val="003B4F"/>
+                </a:solidFill>
+                <a:latin typeface="Courier"/>
+              </a:rPr>
+              <a:t>)</a:t>
+            </a:r>
+            <a:br/>
+            <a:br/>
+            <a:r>
+              <a:rPr>
+                <a:solidFill>
+                  <a:srgbClr val="003B4F"/>
+                </a:solidFill>
+                <a:latin typeface="Courier"/>
+              </a:rPr>
+              <a:t>pine_alpha &lt;- </a:t>
+            </a:r>
+            <a:r>
+              <a:rPr>
+                <a:solidFill>
+                  <a:srgbClr val="AD0000"/>
+                </a:solidFill>
+                <a:latin typeface="Courier"/>
+              </a:rPr>
+              <a:t>0.05</a:t>
+            </a:r>
+            <a:br/>
+            <a:br/>
+            <a:r>
+              <a:rPr>
+                <a:solidFill>
+                  <a:srgbClr val="5E5E5E"/>
+                </a:solidFill>
+                <a:latin typeface="Courier"/>
+              </a:rPr>
+              <a:t># Calculate power for detecting a 30 mm difference</a:t>
+            </a:r>
+            <a:br/>
+            <a:br/>
+            <a:r>
+              <a:rPr>
+                <a:solidFill>
+                  <a:srgbClr val="003B4F"/>
+                </a:solidFill>
+                <a:latin typeface="Courier"/>
+              </a:rPr>
+              <a:t>pine_n1 &lt;- </a:t>
+            </a:r>
+            <a:r>
+              <a:rPr>
+                <a:solidFill>
+                  <a:srgbClr val="4758AB"/>
+                </a:solidFill>
+                <a:latin typeface="Courier"/>
+              </a:rPr>
+              <a:t>nrow</a:t>
+            </a:r>
+            <a:r>
+              <a:rPr>
+                <a:solidFill>
+                  <a:srgbClr val="003B4F"/>
+                </a:solidFill>
+                <a:latin typeface="Courier"/>
+              </a:rPr>
+              <a:t>(ps_shady_df)  </a:t>
+            </a:r>
+            <a:r>
+              <a:rPr>
+                <a:solidFill>
+                  <a:srgbClr val="5E5E5E"/>
+                </a:solidFill>
+                <a:latin typeface="Courier"/>
+              </a:rPr>
+              <a:t># FIX: was using sidney_df instead of ps_shady_df</a:t>
+            </a:r>
+            <a:br/>
+            <a:r>
+              <a:rPr>
+                <a:solidFill>
+                  <a:srgbClr val="003B4F"/>
+                </a:solidFill>
+                <a:latin typeface="Courier"/>
+              </a:rPr>
+              <a:t>pine_n2 &lt;- </a:t>
+            </a:r>
+            <a:r>
+              <a:rPr>
+                <a:solidFill>
+                  <a:srgbClr val="4758AB"/>
+                </a:solidFill>
+                <a:latin typeface="Courier"/>
+              </a:rPr>
+              <a:t>nrow</a:t>
+            </a:r>
+            <a:r>
+              <a:rPr>
+                <a:solidFill>
+                  <a:srgbClr val="003B4F"/>
+                </a:solidFill>
+                <a:latin typeface="Courier"/>
+              </a:rPr>
+              <a:t>(ps_sunny_df)  </a:t>
+            </a:r>
+            <a:r>
+              <a:rPr>
+                <a:solidFill>
+                  <a:srgbClr val="5E5E5E"/>
+                </a:solidFill>
+                <a:latin typeface="Courier"/>
+              </a:rPr>
+              <a:t># FIX: was using vancouver_df instead of ps_sunny_df</a:t>
+            </a:r>
+            <a:br/>
+            <a:br/>
+            <a:r>
+              <a:rPr>
+                <a:solidFill>
+                  <a:srgbClr val="003B4F"/>
+                </a:solidFill>
+                <a:latin typeface="Courier"/>
+              </a:rPr>
+              <a:t>pine_sd_pooled &lt;- </a:t>
+            </a:r>
+            <a:r>
+              <a:rPr>
+                <a:solidFill>
+                  <a:srgbClr val="4758AB"/>
+                </a:solidFill>
+                <a:latin typeface="Courier"/>
+              </a:rPr>
+              <a:t>sqrt</a:t>
+            </a:r>
+            <a:r>
+              <a:rPr>
+                <a:solidFill>
+                  <a:srgbClr val="003B4F"/>
+                </a:solidFill>
+                <a:latin typeface="Courier"/>
+              </a:rPr>
+              <a:t>((</a:t>
+            </a:r>
+            <a:r>
+              <a:rPr>
+                <a:solidFill>
+                  <a:srgbClr val="4758AB"/>
+                </a:solidFill>
+                <a:latin typeface="Courier"/>
+              </a:rPr>
+              <a:t>var</a:t>
+            </a:r>
+            <a:r>
+              <a:rPr>
+                <a:solidFill>
+                  <a:srgbClr val="003B4F"/>
+                </a:solidFill>
+                <a:latin typeface="Courier"/>
+              </a:rPr>
+              <a:t>(ps_shady_df</a:t>
+            </a:r>
+            <a:r>
+              <a:rPr>
+                <a:solidFill>
+                  <a:srgbClr val="5E5E5E"/>
+                </a:solidFill>
+                <a:latin typeface="Courier"/>
+              </a:rPr>
+              <a:t>$</a:t>
+            </a:r>
+            <a:r>
+              <a:rPr>
+                <a:solidFill>
+                  <a:srgbClr val="003B4F"/>
+                </a:solidFill>
+                <a:latin typeface="Courier"/>
+              </a:rPr>
+              <a:t>length_mm) </a:t>
+            </a:r>
+            <a:r>
+              <a:rPr>
+                <a:solidFill>
+                  <a:srgbClr val="5E5E5E"/>
+                </a:solidFill>
+                <a:latin typeface="Courier"/>
+              </a:rPr>
+              <a:t>*</a:t>
+            </a:r>
+            <a:r>
+              <a:rPr>
+                <a:solidFill>
+                  <a:srgbClr val="003B4F"/>
+                </a:solidFill>
+                <a:latin typeface="Courier"/>
+              </a:rPr>
+              <a:t> (pine_n1</a:t>
+            </a:r>
+            <a:r>
+              <a:rPr>
+                <a:solidFill>
+                  <a:srgbClr val="AD0000"/>
+                </a:solidFill>
+                <a:latin typeface="Courier"/>
+              </a:rPr>
+              <a:t>-1</a:t>
+            </a:r>
+            <a:r>
+              <a:rPr>
+                <a:solidFill>
+                  <a:srgbClr val="003B4F"/>
+                </a:solidFill>
+                <a:latin typeface="Courier"/>
+              </a:rPr>
+              <a:t>) </a:t>
+            </a:r>
+            <a:r>
+              <a:rPr>
+                <a:solidFill>
+                  <a:srgbClr val="5E5E5E"/>
+                </a:solidFill>
+                <a:latin typeface="Courier"/>
+              </a:rPr>
+              <a:t>+</a:t>
+            </a:r>
+            <a:r>
+              <a:rPr>
+                <a:solidFill>
+                  <a:srgbClr val="003B4F"/>
+                </a:solidFill>
+                <a:latin typeface="Courier"/>
+              </a:rPr>
+              <a:t> </a:t>
+            </a:r>
+            <a:br/>
+            <a:r>
+              <a:rPr>
+                <a:solidFill>
+                  <a:srgbClr val="003B4F"/>
+                </a:solidFill>
+                <a:latin typeface="Courier"/>
+              </a:rPr>
+              <a:t>                       </a:t>
+            </a:r>
+            <a:r>
+              <a:rPr>
+                <a:solidFill>
+                  <a:srgbClr val="4758AB"/>
+                </a:solidFill>
+                <a:latin typeface="Courier"/>
+              </a:rPr>
+              <a:t>var</a:t>
+            </a:r>
+            <a:r>
+              <a:rPr>
+                <a:solidFill>
+                  <a:srgbClr val="003B4F"/>
+                </a:solidFill>
+                <a:latin typeface="Courier"/>
+              </a:rPr>
+              <a:t>(ps_sunny_df</a:t>
+            </a:r>
+            <a:r>
+              <a:rPr>
+                <a:solidFill>
+                  <a:srgbClr val="5E5E5E"/>
+                </a:solidFill>
+                <a:latin typeface="Courier"/>
+              </a:rPr>
+              <a:t>$</a:t>
+            </a:r>
+            <a:r>
+              <a:rPr>
+                <a:solidFill>
+                  <a:srgbClr val="003B4F"/>
+                </a:solidFill>
+                <a:latin typeface="Courier"/>
+              </a:rPr>
+              <a:t>length_mm) </a:t>
+            </a:r>
+            <a:r>
+              <a:rPr>
+                <a:solidFill>
+                  <a:srgbClr val="5E5E5E"/>
+                </a:solidFill>
+                <a:latin typeface="Courier"/>
+              </a:rPr>
+              <a:t>*</a:t>
+            </a:r>
+            <a:r>
+              <a:rPr>
+                <a:solidFill>
+                  <a:srgbClr val="003B4F"/>
+                </a:solidFill>
+                <a:latin typeface="Courier"/>
+              </a:rPr>
+              <a:t> (pine_n2</a:t>
+            </a:r>
+            <a:r>
+              <a:rPr>
+                <a:solidFill>
+                  <a:srgbClr val="AD0000"/>
+                </a:solidFill>
+                <a:latin typeface="Courier"/>
+              </a:rPr>
+              <a:t>-1</a:t>
+            </a:r>
+            <a:r>
+              <a:rPr>
+                <a:solidFill>
+                  <a:srgbClr val="003B4F"/>
+                </a:solidFill>
+                <a:latin typeface="Courier"/>
+              </a:rPr>
+              <a:t>)) </a:t>
+            </a:r>
+            <a:r>
+              <a:rPr>
+                <a:solidFill>
+                  <a:srgbClr val="5E5E5E"/>
+                </a:solidFill>
+                <a:latin typeface="Courier"/>
+              </a:rPr>
+              <a:t>/</a:t>
+            </a:r>
+            <a:r>
+              <a:rPr>
+                <a:solidFill>
+                  <a:srgbClr val="003B4F"/>
+                </a:solidFill>
+                <a:latin typeface="Courier"/>
+              </a:rPr>
+              <a:t> </a:t>
+            </a:r>
+            <a:br/>
+            <a:r>
+              <a:rPr>
+                <a:solidFill>
+                  <a:srgbClr val="003B4F"/>
+                </a:solidFill>
+                <a:latin typeface="Courier"/>
+              </a:rPr>
+              <a:t>                       (pine_n1 </a:t>
+            </a:r>
+            <a:r>
+              <a:rPr>
+                <a:solidFill>
+                  <a:srgbClr val="5E5E5E"/>
+                </a:solidFill>
+                <a:latin typeface="Courier"/>
+              </a:rPr>
+              <a:t>+</a:t>
+            </a:r>
+            <a:r>
+              <a:rPr>
+                <a:solidFill>
+                  <a:srgbClr val="003B4F"/>
+                </a:solidFill>
+                <a:latin typeface="Courier"/>
+              </a:rPr>
+              <a:t> pine_n2 </a:t>
+            </a:r>
+            <a:r>
+              <a:rPr>
+                <a:solidFill>
+                  <a:srgbClr val="5E5E5E"/>
+                </a:solidFill>
+                <a:latin typeface="Courier"/>
+              </a:rPr>
+              <a:t>-</a:t>
+            </a:r>
+            <a:r>
+              <a:rPr>
+                <a:solidFill>
+                  <a:srgbClr val="003B4F"/>
+                </a:solidFill>
+                <a:latin typeface="Courier"/>
+              </a:rPr>
+              <a:t> </a:t>
+            </a:r>
+            <a:r>
+              <a:rPr>
+                <a:solidFill>
+                  <a:srgbClr val="AD0000"/>
+                </a:solidFill>
+                <a:latin typeface="Courier"/>
+              </a:rPr>
+              <a:t>2</a:t>
+            </a:r>
+            <a:r>
+              <a:rPr>
+                <a:solidFill>
+                  <a:srgbClr val="003B4F"/>
+                </a:solidFill>
+                <a:latin typeface="Courier"/>
+              </a:rPr>
+              <a:t>))  </a:t>
+            </a:r>
+            <a:r>
+              <a:rPr>
+                <a:solidFill>
+                  <a:srgbClr val="5E5E5E"/>
+                </a:solidFill>
+                <a:latin typeface="Courier"/>
+              </a:rPr>
+              <a:t># FIX: was using n1, n2 instead of pine_n1, pine_n2</a:t>
+            </a:r>
+            <a:br/>
+            <a:br/>
+            <a:r>
+              <a:rPr>
+                <a:solidFill>
+                  <a:srgbClr val="4758AB"/>
+                </a:solidFill>
+                <a:latin typeface="Courier"/>
+              </a:rPr>
+              <a:t>cat</a:t>
+            </a:r>
+            <a:r>
+              <a:rPr>
+                <a:solidFill>
+                  <a:srgbClr val="003B4F"/>
+                </a:solidFill>
+                <a:latin typeface="Courier"/>
+              </a:rPr>
+              <a:t>(</a:t>
+            </a:r>
+            <a:r>
+              <a:rPr>
+                <a:solidFill>
+                  <a:srgbClr val="20794D"/>
+                </a:solidFill>
+                <a:latin typeface="Courier"/>
+              </a:rPr>
+              <a:t>"Pooled SD:"</a:t>
+            </a:r>
+            <a:r>
+              <a:rPr>
+                <a:solidFill>
+                  <a:srgbClr val="003B4F"/>
+                </a:solidFill>
+                <a:latin typeface="Courier"/>
+              </a:rPr>
+              <a:t>, </a:t>
+            </a:r>
+            <a:r>
+              <a:rPr>
+                <a:solidFill>
+                  <a:srgbClr val="4758AB"/>
+                </a:solidFill>
+                <a:latin typeface="Courier"/>
+              </a:rPr>
+              <a:t>round</a:t>
+            </a:r>
+            <a:r>
+              <a:rPr>
+                <a:solidFill>
+                  <a:srgbClr val="003B4F"/>
+                </a:solidFill>
+                <a:latin typeface="Courier"/>
+              </a:rPr>
+              <a:t>(pine_sd_pooled, </a:t>
+            </a:r>
+            <a:r>
+              <a:rPr>
+                <a:solidFill>
+                  <a:srgbClr val="AD0000"/>
+                </a:solidFill>
+                <a:latin typeface="Courier"/>
+              </a:rPr>
+              <a:t>2</a:t>
+            </a:r>
+            <a:r>
+              <a:rPr>
+                <a:solidFill>
+                  <a:srgbClr val="003B4F"/>
+                </a:solidFill>
+                <a:latin typeface="Courier"/>
+              </a:rPr>
+              <a:t>), </a:t>
+            </a:r>
+            <a:r>
+              <a:rPr>
+                <a:solidFill>
+                  <a:srgbClr val="20794D"/>
+                </a:solidFill>
+                <a:latin typeface="Courier"/>
+              </a:rPr>
+              <a:t>"mm</a:t>
+            </a:r>
+            <a:r>
+              <a:rPr>
+                <a:solidFill>
+                  <a:srgbClr val="5E5E5E"/>
+                </a:solidFill>
+                <a:latin typeface="Courier"/>
+              </a:rPr>
+              <a:t>\n\n</a:t>
+            </a:r>
+            <a:r>
+              <a:rPr>
+                <a:solidFill>
+                  <a:srgbClr val="20794D"/>
+                </a:solidFill>
+                <a:latin typeface="Courier"/>
+              </a:rPr>
+              <a:t>"</a:t>
+            </a:r>
+            <a:r>
+              <a:rPr>
+                <a:solidFill>
+                  <a:srgbClr val="003B4F"/>
+                </a:solidFill>
+                <a:latin typeface="Courier"/>
+              </a:rPr>
+              <a:t>)</a:t>
+            </a:r>
+          </a:p>
+          <a:p>
+            <a:pPr lvl="0" indent="0">
               <a:buNone/>
             </a:pPr>
             <a:r>
-              <a:rPr/>
-              <a:t>A power analysis like this is typically done for one of these purposes:</a:t>
-            </a:r>
-          </a:p>
-          <a:p>
-            <a:pPr lvl="0" indent="-342900" marL="342900">
-              <a:buAutoNum type="arabicPeriod"/>
+              <a:rPr>
+                <a:latin typeface="Courier"/>
+              </a:rPr>
+              <a:t>Pooled SD: 2.58 mm</a:t>
+            </a:r>
+          </a:p>
+          <a:p>
+            <a:pPr lvl="0" indent="0">
+              <a:buNone/>
             </a:pPr>
             <a:r>
-              <a:rPr/>
-              <a:t>Before data collection to determine required sample size</a:t>
-            </a:r>
-          </a:p>
-          <a:p>
-            <a:pPr lvl="0" indent="-342900" marL="342900">
-              <a:buAutoNum type="arabicPeriod"/>
+              <a:rPr>
+                <a:solidFill>
+                  <a:srgbClr val="5E5E5E"/>
+                </a:solidFill>
+                <a:latin typeface="Courier"/>
+              </a:rPr>
+              <a:t># More realistic effect sizes to test:</a:t>
+            </a:r>
+            <a:br/>
+            <a:r>
+              <a:rPr>
+                <a:solidFill>
+                  <a:srgbClr val="003B4F"/>
+                </a:solidFill>
+                <a:latin typeface="Courier"/>
+              </a:rPr>
+              <a:t>observed_diff &lt;- </a:t>
+            </a:r>
+            <a:r>
+              <a:rPr>
+                <a:solidFill>
+                  <a:srgbClr val="4758AB"/>
+                </a:solidFill>
+                <a:latin typeface="Courier"/>
+              </a:rPr>
+              <a:t>abs</a:t>
+            </a:r>
+            <a:r>
+              <a:rPr>
+                <a:solidFill>
+                  <a:srgbClr val="003B4F"/>
+                </a:solidFill>
+                <a:latin typeface="Courier"/>
+              </a:rPr>
+              <a:t>(</a:t>
+            </a:r>
+            <a:r>
+              <a:rPr>
+                <a:solidFill>
+                  <a:srgbClr val="4758AB"/>
+                </a:solidFill>
+                <a:latin typeface="Courier"/>
+              </a:rPr>
+              <a:t>mean</a:t>
+            </a:r>
+            <a:r>
+              <a:rPr>
+                <a:solidFill>
+                  <a:srgbClr val="003B4F"/>
+                </a:solidFill>
+                <a:latin typeface="Courier"/>
+              </a:rPr>
+              <a:t>(ps_shady_df</a:t>
+            </a:r>
+            <a:r>
+              <a:rPr>
+                <a:solidFill>
+                  <a:srgbClr val="5E5E5E"/>
+                </a:solidFill>
+                <a:latin typeface="Courier"/>
+              </a:rPr>
+              <a:t>$</a:t>
+            </a:r>
+            <a:r>
+              <a:rPr>
+                <a:solidFill>
+                  <a:srgbClr val="003B4F"/>
+                </a:solidFill>
+                <a:latin typeface="Courier"/>
+              </a:rPr>
+              <a:t>length_mm) </a:t>
+            </a:r>
+            <a:r>
+              <a:rPr>
+                <a:solidFill>
+                  <a:srgbClr val="5E5E5E"/>
+                </a:solidFill>
+                <a:latin typeface="Courier"/>
+              </a:rPr>
+              <a:t>-</a:t>
+            </a:r>
+            <a:r>
+              <a:rPr>
+                <a:solidFill>
+                  <a:srgbClr val="003B4F"/>
+                </a:solidFill>
+                <a:latin typeface="Courier"/>
+              </a:rPr>
+              <a:t> </a:t>
+            </a:r>
+            <a:r>
+              <a:rPr>
+                <a:solidFill>
+                  <a:srgbClr val="4758AB"/>
+                </a:solidFill>
+                <a:latin typeface="Courier"/>
+              </a:rPr>
+              <a:t>mean</a:t>
+            </a:r>
+            <a:r>
+              <a:rPr>
+                <a:solidFill>
+                  <a:srgbClr val="003B4F"/>
+                </a:solidFill>
+                <a:latin typeface="Courier"/>
+              </a:rPr>
+              <a:t>(ps_sunny_df</a:t>
+            </a:r>
+            <a:r>
+              <a:rPr>
+                <a:solidFill>
+                  <a:srgbClr val="5E5E5E"/>
+                </a:solidFill>
+                <a:latin typeface="Courier"/>
+              </a:rPr>
+              <a:t>$</a:t>
+            </a:r>
+            <a:r>
+              <a:rPr>
+                <a:solidFill>
+                  <a:srgbClr val="003B4F"/>
+                </a:solidFill>
+                <a:latin typeface="Courier"/>
+              </a:rPr>
+              <a:t>length_mm))</a:t>
+            </a:r>
+            <a:br/>
+            <a:r>
+              <a:rPr>
+                <a:solidFill>
+                  <a:srgbClr val="003B4F"/>
+                </a:solidFill>
+                <a:latin typeface="Courier"/>
+              </a:rPr>
+              <a:t>pine_effect_size_observed &lt;- observed_diff </a:t>
+            </a:r>
+            <a:r>
+              <a:rPr>
+                <a:solidFill>
+                  <a:srgbClr val="5E5E5E"/>
+                </a:solidFill>
+                <a:latin typeface="Courier"/>
+              </a:rPr>
+              <a:t>/</a:t>
+            </a:r>
+            <a:r>
+              <a:rPr>
+                <a:solidFill>
+                  <a:srgbClr val="003B4F"/>
+                </a:solidFill>
+                <a:latin typeface="Courier"/>
+              </a:rPr>
+              <a:t> pine_sd_pooled</a:t>
+            </a:r>
+            <a:br/>
+            <a:r>
+              <a:rPr>
+                <a:solidFill>
+                  <a:srgbClr val="4758AB"/>
+                </a:solidFill>
+                <a:latin typeface="Courier"/>
+              </a:rPr>
+              <a:t>cat</a:t>
+            </a:r>
+            <a:r>
+              <a:rPr>
+                <a:solidFill>
+                  <a:srgbClr val="003B4F"/>
+                </a:solidFill>
+                <a:latin typeface="Courier"/>
+              </a:rPr>
+              <a:t>(</a:t>
+            </a:r>
+            <a:r>
+              <a:rPr>
+                <a:solidFill>
+                  <a:srgbClr val="20794D"/>
+                </a:solidFill>
+                <a:latin typeface="Courier"/>
+              </a:rPr>
+              <a:t>"Effect size for observed"</a:t>
+            </a:r>
+            <a:r>
+              <a:rPr>
+                <a:solidFill>
+                  <a:srgbClr val="003B4F"/>
+                </a:solidFill>
+                <a:latin typeface="Courier"/>
+              </a:rPr>
+              <a:t>, </a:t>
+            </a:r>
+            <a:r>
+              <a:rPr>
+                <a:solidFill>
+                  <a:srgbClr val="4758AB"/>
+                </a:solidFill>
+                <a:latin typeface="Courier"/>
+              </a:rPr>
+              <a:t>round</a:t>
+            </a:r>
+            <a:r>
+              <a:rPr>
+                <a:solidFill>
+                  <a:srgbClr val="003B4F"/>
+                </a:solidFill>
+                <a:latin typeface="Courier"/>
+              </a:rPr>
+              <a:t>(observed_diff, </a:t>
+            </a:r>
+            <a:r>
+              <a:rPr>
+                <a:solidFill>
+                  <a:srgbClr val="AD0000"/>
+                </a:solidFill>
+                <a:latin typeface="Courier"/>
+              </a:rPr>
+              <a:t>2</a:t>
+            </a:r>
+            <a:r>
+              <a:rPr>
+                <a:solidFill>
+                  <a:srgbClr val="003B4F"/>
+                </a:solidFill>
+                <a:latin typeface="Courier"/>
+              </a:rPr>
+              <a:t>), </a:t>
+            </a:r>
+            <a:r>
+              <a:rPr>
+                <a:solidFill>
+                  <a:srgbClr val="20794D"/>
+                </a:solidFill>
+                <a:latin typeface="Courier"/>
+              </a:rPr>
+              <a:t>"mm difference: Cohen's d ="</a:t>
+            </a:r>
+            <a:r>
+              <a:rPr>
+                <a:solidFill>
+                  <a:srgbClr val="003B4F"/>
+                </a:solidFill>
+                <a:latin typeface="Courier"/>
+              </a:rPr>
+              <a:t>, </a:t>
+            </a:r>
+            <a:r>
+              <a:rPr>
+                <a:solidFill>
+                  <a:srgbClr val="4758AB"/>
+                </a:solidFill>
+                <a:latin typeface="Courier"/>
+              </a:rPr>
+              <a:t>round</a:t>
+            </a:r>
+            <a:r>
+              <a:rPr>
+                <a:solidFill>
+                  <a:srgbClr val="003B4F"/>
+                </a:solidFill>
+                <a:latin typeface="Courier"/>
+              </a:rPr>
+              <a:t>(pine_effect_size_observed, </a:t>
+            </a:r>
+            <a:r>
+              <a:rPr>
+                <a:solidFill>
+                  <a:srgbClr val="AD0000"/>
+                </a:solidFill>
+                <a:latin typeface="Courier"/>
+              </a:rPr>
+              <a:t>2</a:t>
+            </a:r>
+            <a:r>
+              <a:rPr>
+                <a:solidFill>
+                  <a:srgbClr val="003B4F"/>
+                </a:solidFill>
+                <a:latin typeface="Courier"/>
+              </a:rPr>
+              <a:t>), </a:t>
+            </a:r>
+            <a:r>
+              <a:rPr>
+                <a:solidFill>
+                  <a:srgbClr val="20794D"/>
+                </a:solidFill>
+                <a:latin typeface="Courier"/>
+              </a:rPr>
+              <a:t>"</a:t>
+            </a:r>
+            <a:r>
+              <a:rPr>
+                <a:solidFill>
+                  <a:srgbClr val="5E5E5E"/>
+                </a:solidFill>
+                <a:latin typeface="Courier"/>
+              </a:rPr>
+              <a:t>\n</a:t>
+            </a:r>
+            <a:r>
+              <a:rPr>
+                <a:solidFill>
+                  <a:srgbClr val="20794D"/>
+                </a:solidFill>
+                <a:latin typeface="Courier"/>
+              </a:rPr>
+              <a:t>"</a:t>
+            </a:r>
+            <a:r>
+              <a:rPr>
+                <a:solidFill>
+                  <a:srgbClr val="003B4F"/>
+                </a:solidFill>
+                <a:latin typeface="Courier"/>
+              </a:rPr>
+              <a:t>)</a:t>
+            </a:r>
+          </a:p>
+          <a:p>
+            <a:pPr lvl="0" indent="0">
+              <a:buNone/>
             </a:pPr>
             <a:r>
-              <a:rPr/>
-              <a:t>After a study to evaluate if the sample size was adequate</a:t>
-            </a:r>
-          </a:p>
-          <a:p>
-            <a:pPr lvl="0" indent="-342900" marL="342900">
-              <a:buAutoNum type="arabicPeriod"/>
+              <a:rPr>
+                <a:latin typeface="Courier"/>
+              </a:rPr>
+              <a:t>Effect size for observed 1.45 mm difference: Cohen's d = 0.56 </a:t>
+            </a:r>
+          </a:p>
+          <a:p>
+            <a:pPr lvl="0" indent="0">
+              <a:buNone/>
             </a:pPr>
             <a:r>
-              <a:rPr/>
-              <a:t>To determine the minimum detectable effect size with the given sample</a:t>
-            </a:r>
-          </a:p>
-          <a:p>
-            <a:pPr lvl="0" indent="0" marL="0">
+              <a:rPr>
+                <a:solidFill>
+                  <a:srgbClr val="5E5E5E"/>
+                </a:solidFill>
+                <a:latin typeface="Courier"/>
+              </a:rPr>
+              <a:t># 2. Power for the observed difference</a:t>
+            </a:r>
+            <a:br/>
+            <a:r>
+              <a:rPr>
+                <a:solidFill>
+                  <a:srgbClr val="003B4F"/>
+                </a:solidFill>
+                <a:latin typeface="Courier"/>
+              </a:rPr>
+              <a:t>pine_power_observed &lt;- </a:t>
+            </a:r>
+            <a:r>
+              <a:rPr>
+                <a:solidFill>
+                  <a:srgbClr val="4758AB"/>
+                </a:solidFill>
+                <a:latin typeface="Courier"/>
+              </a:rPr>
+              <a:t>power.t.test</a:t>
+            </a:r>
+            <a:r>
+              <a:rPr>
+                <a:solidFill>
+                  <a:srgbClr val="003B4F"/>
+                </a:solidFill>
+                <a:latin typeface="Courier"/>
+              </a:rPr>
+              <a:t>(</a:t>
+            </a:r>
+            <a:r>
+              <a:rPr>
+                <a:solidFill>
+                  <a:srgbClr val="657422"/>
+                </a:solidFill>
+                <a:latin typeface="Courier"/>
+              </a:rPr>
+              <a:t>n =</a:t>
+            </a:r>
+            <a:r>
+              <a:rPr>
+                <a:solidFill>
+                  <a:srgbClr val="003B4F"/>
+                </a:solidFill>
+                <a:latin typeface="Courier"/>
+              </a:rPr>
+              <a:t> </a:t>
+            </a:r>
+            <a:r>
+              <a:rPr>
+                <a:solidFill>
+                  <a:srgbClr val="4758AB"/>
+                </a:solidFill>
+                <a:latin typeface="Courier"/>
+              </a:rPr>
+              <a:t>min</a:t>
+            </a:r>
+            <a:r>
+              <a:rPr>
+                <a:solidFill>
+                  <a:srgbClr val="003B4F"/>
+                </a:solidFill>
+                <a:latin typeface="Courier"/>
+              </a:rPr>
+              <a:t>(pine_n1, pine_n2), </a:t>
+            </a:r>
+            <a:br/>
+            <a:r>
+              <a:rPr>
+                <a:solidFill>
+                  <a:srgbClr val="003B4F"/>
+                </a:solidFill>
+                <a:latin typeface="Courier"/>
+              </a:rPr>
+              <a:t>                                   </a:t>
+            </a:r>
+            <a:r>
+              <a:rPr>
+                <a:solidFill>
+                  <a:srgbClr val="657422"/>
+                </a:solidFill>
+                <a:latin typeface="Courier"/>
+              </a:rPr>
+              <a:t>delta =</a:t>
+            </a:r>
+            <a:r>
+              <a:rPr>
+                <a:solidFill>
+                  <a:srgbClr val="003B4F"/>
+                </a:solidFill>
+                <a:latin typeface="Courier"/>
+              </a:rPr>
+              <a:t> pine_effect_size_observed,</a:t>
+            </a:r>
+            <a:br/>
+            <a:r>
+              <a:rPr>
+                <a:solidFill>
+                  <a:srgbClr val="003B4F"/>
+                </a:solidFill>
+                <a:latin typeface="Courier"/>
+              </a:rPr>
+              <a:t>                                   </a:t>
+            </a:r>
+            <a:r>
+              <a:rPr>
+                <a:solidFill>
+                  <a:srgbClr val="657422"/>
+                </a:solidFill>
+                <a:latin typeface="Courier"/>
+              </a:rPr>
+              <a:t>sd =</a:t>
+            </a:r>
+            <a:r>
+              <a:rPr>
+                <a:solidFill>
+                  <a:srgbClr val="003B4F"/>
+                </a:solidFill>
+                <a:latin typeface="Courier"/>
+              </a:rPr>
+              <a:t> </a:t>
+            </a:r>
+            <a:r>
+              <a:rPr>
+                <a:solidFill>
+                  <a:srgbClr val="AD0000"/>
+                </a:solidFill>
+                <a:latin typeface="Courier"/>
+              </a:rPr>
+              <a:t>1</a:t>
+            </a:r>
+            <a:r>
+              <a:rPr>
+                <a:solidFill>
+                  <a:srgbClr val="003B4F"/>
+                </a:solidFill>
+                <a:latin typeface="Courier"/>
+              </a:rPr>
+              <a:t>,</a:t>
+            </a:r>
+            <a:br/>
+            <a:r>
+              <a:rPr>
+                <a:solidFill>
+                  <a:srgbClr val="003B4F"/>
+                </a:solidFill>
+                <a:latin typeface="Courier"/>
+              </a:rPr>
+              <a:t>                                   </a:t>
+            </a:r>
+            <a:r>
+              <a:rPr>
+                <a:solidFill>
+                  <a:srgbClr val="657422"/>
+                </a:solidFill>
+                <a:latin typeface="Courier"/>
+              </a:rPr>
+              <a:t>sig.level =</a:t>
+            </a:r>
+            <a:r>
+              <a:rPr>
+                <a:solidFill>
+                  <a:srgbClr val="003B4F"/>
+                </a:solidFill>
+                <a:latin typeface="Courier"/>
+              </a:rPr>
+              <a:t> pine_alpha,</a:t>
+            </a:r>
+            <a:br/>
+            <a:r>
+              <a:rPr>
+                <a:solidFill>
+                  <a:srgbClr val="003B4F"/>
+                </a:solidFill>
+                <a:latin typeface="Courier"/>
+              </a:rPr>
+              <a:t>                                   </a:t>
+            </a:r>
+            <a:r>
+              <a:rPr>
+                <a:solidFill>
+                  <a:srgbClr val="657422"/>
+                </a:solidFill>
+                <a:latin typeface="Courier"/>
+              </a:rPr>
+              <a:t>type =</a:t>
+            </a:r>
+            <a:r>
+              <a:rPr>
+                <a:solidFill>
+                  <a:srgbClr val="003B4F"/>
+                </a:solidFill>
+                <a:latin typeface="Courier"/>
+              </a:rPr>
+              <a:t> </a:t>
+            </a:r>
+            <a:r>
+              <a:rPr>
+                <a:solidFill>
+                  <a:srgbClr val="20794D"/>
+                </a:solidFill>
+                <a:latin typeface="Courier"/>
+              </a:rPr>
+              <a:t>"two.sample"</a:t>
+            </a:r>
+            <a:r>
+              <a:rPr>
+                <a:solidFill>
+                  <a:srgbClr val="003B4F"/>
+                </a:solidFill>
+                <a:latin typeface="Courier"/>
+              </a:rPr>
+              <a:t>,</a:t>
+            </a:r>
+            <a:br/>
+            <a:r>
+              <a:rPr>
+                <a:solidFill>
+                  <a:srgbClr val="003B4F"/>
+                </a:solidFill>
+                <a:latin typeface="Courier"/>
+              </a:rPr>
+              <a:t>                                   </a:t>
+            </a:r>
+            <a:r>
+              <a:rPr>
+                <a:solidFill>
+                  <a:srgbClr val="657422"/>
+                </a:solidFill>
+                <a:latin typeface="Courier"/>
+              </a:rPr>
+              <a:t>alternative =</a:t>
+            </a:r>
+            <a:r>
+              <a:rPr>
+                <a:solidFill>
+                  <a:srgbClr val="003B4F"/>
+                </a:solidFill>
+                <a:latin typeface="Courier"/>
+              </a:rPr>
+              <a:t> </a:t>
+            </a:r>
+            <a:r>
+              <a:rPr>
+                <a:solidFill>
+                  <a:srgbClr val="20794D"/>
+                </a:solidFill>
+                <a:latin typeface="Courier"/>
+              </a:rPr>
+              <a:t>"two.sided"</a:t>
+            </a:r>
+            <a:r>
+              <a:rPr>
+                <a:solidFill>
+                  <a:srgbClr val="003B4F"/>
+                </a:solidFill>
+                <a:latin typeface="Courier"/>
+              </a:rPr>
+              <a:t>)</a:t>
+            </a:r>
+            <a:br/>
+            <a:br/>
+            <a:r>
+              <a:rPr>
+                <a:solidFill>
+                  <a:srgbClr val="4758AB"/>
+                </a:solidFill>
+                <a:latin typeface="Courier"/>
+              </a:rPr>
+              <a:t>cat</a:t>
+            </a:r>
+            <a:r>
+              <a:rPr>
+                <a:solidFill>
+                  <a:srgbClr val="003B4F"/>
+                </a:solidFill>
+                <a:latin typeface="Courier"/>
+              </a:rPr>
+              <a:t>(</a:t>
+            </a:r>
+            <a:r>
+              <a:rPr>
+                <a:solidFill>
+                  <a:srgbClr val="20794D"/>
+                </a:solidFill>
+                <a:latin typeface="Courier"/>
+              </a:rPr>
+              <a:t>"Power for observed"</a:t>
+            </a:r>
+            <a:r>
+              <a:rPr>
+                <a:solidFill>
+                  <a:srgbClr val="003B4F"/>
+                </a:solidFill>
+                <a:latin typeface="Courier"/>
+              </a:rPr>
+              <a:t>, </a:t>
+            </a:r>
+            <a:r>
+              <a:rPr>
+                <a:solidFill>
+                  <a:srgbClr val="4758AB"/>
+                </a:solidFill>
+                <a:latin typeface="Courier"/>
+              </a:rPr>
+              <a:t>round</a:t>
+            </a:r>
+            <a:r>
+              <a:rPr>
+                <a:solidFill>
+                  <a:srgbClr val="003B4F"/>
+                </a:solidFill>
+                <a:latin typeface="Courier"/>
+              </a:rPr>
+              <a:t>(observed_diff, </a:t>
+            </a:r>
+            <a:r>
+              <a:rPr>
+                <a:solidFill>
+                  <a:srgbClr val="AD0000"/>
+                </a:solidFill>
+                <a:latin typeface="Courier"/>
+              </a:rPr>
+              <a:t>2</a:t>
+            </a:r>
+            <a:r>
+              <a:rPr>
+                <a:solidFill>
+                  <a:srgbClr val="003B4F"/>
+                </a:solidFill>
+                <a:latin typeface="Courier"/>
+              </a:rPr>
+              <a:t>), </a:t>
+            </a:r>
+            <a:r>
+              <a:rPr>
+                <a:solidFill>
+                  <a:srgbClr val="20794D"/>
+                </a:solidFill>
+                <a:latin typeface="Courier"/>
+              </a:rPr>
+              <a:t>"mm difference:"</a:t>
+            </a:r>
+            <a:r>
+              <a:rPr>
+                <a:solidFill>
+                  <a:srgbClr val="003B4F"/>
+                </a:solidFill>
+                <a:latin typeface="Courier"/>
+              </a:rPr>
+              <a:t>, </a:t>
+            </a:r>
+            <a:r>
+              <a:rPr>
+                <a:solidFill>
+                  <a:srgbClr val="4758AB"/>
+                </a:solidFill>
+                <a:latin typeface="Courier"/>
+              </a:rPr>
+              <a:t>round</a:t>
+            </a:r>
+            <a:r>
+              <a:rPr>
+                <a:solidFill>
+                  <a:srgbClr val="003B4F"/>
+                </a:solidFill>
+                <a:latin typeface="Courier"/>
+              </a:rPr>
+              <a:t>(pine_power_observed</a:t>
+            </a:r>
+            <a:r>
+              <a:rPr>
+                <a:solidFill>
+                  <a:srgbClr val="5E5E5E"/>
+                </a:solidFill>
+                <a:latin typeface="Courier"/>
+              </a:rPr>
+              <a:t>$</a:t>
+            </a:r>
+            <a:r>
+              <a:rPr>
+                <a:solidFill>
+                  <a:srgbClr val="003B4F"/>
+                </a:solidFill>
+                <a:latin typeface="Courier"/>
+              </a:rPr>
+              <a:t>power, </a:t>
+            </a:r>
+            <a:r>
+              <a:rPr>
+                <a:solidFill>
+                  <a:srgbClr val="AD0000"/>
+                </a:solidFill>
+                <a:latin typeface="Courier"/>
+              </a:rPr>
+              <a:t>3</a:t>
+            </a:r>
+            <a:r>
+              <a:rPr>
+                <a:solidFill>
+                  <a:srgbClr val="003B4F"/>
+                </a:solidFill>
+                <a:latin typeface="Courier"/>
+              </a:rPr>
+              <a:t>), </a:t>
+            </a:r>
+            <a:r>
+              <a:rPr>
+                <a:solidFill>
+                  <a:srgbClr val="20794D"/>
+                </a:solidFill>
+                <a:latin typeface="Courier"/>
+              </a:rPr>
+              <a:t>"</a:t>
+            </a:r>
+            <a:r>
+              <a:rPr>
+                <a:solidFill>
+                  <a:srgbClr val="5E5E5E"/>
+                </a:solidFill>
+                <a:latin typeface="Courier"/>
+              </a:rPr>
+              <a:t>\n</a:t>
+            </a:r>
+            <a:r>
+              <a:rPr>
+                <a:solidFill>
+                  <a:srgbClr val="20794D"/>
+                </a:solidFill>
+                <a:latin typeface="Courier"/>
+              </a:rPr>
+              <a:t>"</a:t>
+            </a:r>
+            <a:r>
+              <a:rPr>
+                <a:solidFill>
+                  <a:srgbClr val="003B4F"/>
+                </a:solidFill>
+                <a:latin typeface="Courier"/>
+              </a:rPr>
+              <a:t>)</a:t>
+            </a:r>
+          </a:p>
+          <a:p>
+            <a:pPr lvl="0" indent="0">
               <a:buNone/>
             </a:pPr>
             <a:r>
-              <a:rPr/>
-              <a:t>With 97% power, this test has excellent ability to detect the specified effect size. Generally, </a:t>
-            </a:r>
-            <a:r>
-              <a:rPr b="1"/>
-              <a:t>80% power is considered acceptable</a:t>
-            </a:r>
-            <a:r>
-              <a:rPr/>
-              <a:t>, so 97% indicates a very well-powered study for detecting a difference of 30mm between the groups.</a:t>
+              <a:rPr>
+                <a:latin typeface="Courier"/>
+              </a:rPr>
+              <a:t>Power for observed 1.45 mm difference: 0.182 </a:t>
             </a:r>
           </a:p>
         </p:txBody>
@@ -6248,11 +8004,8 @@
         <p:spPr>
           <a:xfrm>
             <a:off x="0" y="0"/>
-            <a:ext cx="9144000" cy="602780"/>
+            <a:ext cx="9144000" cy="582780"/>
           </a:xfrm>
-          <a:solidFill>
-            <a:srgbClr val="70121D"/>
-          </a:solidFill>
         </p:spPr>
         <p:txBody>
           <a:bodyPr/>
@@ -6262,12 +8015,8 @@
               <a:buNone/>
             </a:pPr>
             <a:r>
-              <a:rPr b="1"/>
-              <a:t>Lecture 6:</a:t>
-            </a:r>
-            <a:r>
-              <a:rPr/>
-              <a:t> Error Bars and Their Interpretation</a:t>
+              <a:rPr/>
+              <a:t>What is Power</a:t>
             </a:r>
           </a:p>
         </p:txBody>
@@ -6279,7 +8028,7 @@
             <a:spLocks noGrp="1"/>
           </p:cNvSpPr>
           <p:nvPr>
-            <p:ph idx="1" sz="half"/>
+            <p:ph idx="1"/>
           </p:nvPr>
         </p:nvSpPr>
         <p:spPr/>
@@ -6292,52 +8041,7 @@
             </a:pPr>
             <a:r>
               <a:rPr/>
-              <a:t>Error bars are graphical representations of the variability of data that show:</a:t>
-            </a:r>
-          </a:p>
-          <a:p>
-            <a:pPr lvl="0"/>
-            <a:r>
-              <a:rPr/>
-              <a:t>The </a:t>
-            </a:r>
-            <a:r>
-              <a:rPr b="1"/>
-              <a:t>precision</a:t>
-            </a:r>
-            <a:r>
-              <a:rPr/>
-              <a:t> of a measurement</a:t>
-            </a:r>
-          </a:p>
-          <a:p>
-            <a:pPr lvl="0"/>
-            <a:r>
-              <a:rPr/>
-              <a:t>The </a:t>
-            </a:r>
-            <a:r>
-              <a:rPr b="1"/>
-              <a:t>uncertainty</a:t>
-            </a:r>
-            <a:r>
-              <a:rPr/>
-              <a:t> around an estimate</a:t>
-            </a:r>
-          </a:p>
-          <a:p>
-            <a:pPr lvl="0"/>
-            <a:r>
-              <a:rPr/>
-              <a:t>A </a:t>
-            </a:r>
-            <a:r>
-              <a:rPr b="1"/>
-              <a:t>confidence interval</a:t>
-            </a:r>
-            <a:r>
-              <a:rPr/>
-              <a:t> for a parameter</a:t>
+              <a:t>Statistical power represents the probability of detecting a true effect (rejecting the null hypothesis when it is false). In this case, with a power of 97%, there’s a 97% chance of detecting a true difference of X units between the means of the two groups if such a difference actually exists.</a:t>
             </a:r>
           </a:p>
           <a:p>
@@ -6346,7 +8050,7 @@
             </a:pPr>
             <a:r>
               <a:rPr/>
-              <a:t>Common types of error bars:</a:t>
+              <a:t>A power analysis like this is typically done for one of these purposes:</a:t>
             </a:r>
           </a:p>
           <a:p>
@@ -6354,12 +8058,8 @@
               <a:buAutoNum type="arabicPeriod"/>
             </a:pPr>
             <a:r>
-              <a:rPr b="1"/>
-              <a:t>Standard Error (SE)</a:t>
-            </a:r>
-            <a:r>
-              <a:rPr/>
-              <a:t>: Shows precision of the mean</a:t>
+              <a:rPr/>
+              <a:t>Before data collection to determine required sample size</a:t>
             </a:r>
           </a:p>
           <a:p>
@@ -6367,12 +8067,8 @@
               <a:buAutoNum type="arabicPeriod"/>
             </a:pPr>
             <a:r>
-              <a:rPr b="1"/>
-              <a:t>Standard Deviation (SD)</a:t>
-            </a:r>
-            <a:r>
-              <a:rPr/>
-              <a:t>: Shows variability in the data</a:t>
+              <a:rPr/>
+              <a:t>After a study to evaluate if the sample size was adequate</a:t>
             </a:r>
           </a:p>
           <a:p>
@@ -6380,76 +8076,29 @@
               <a:buAutoNum type="arabicPeriod"/>
             </a:pPr>
             <a:r>
+              <a:rPr/>
+              <a:t>To determine the minimum detectable effect size with the given sample</a:t>
+            </a:r>
+          </a:p>
+          <a:p>
+            <a:pPr lvl="0" indent="0" marL="0">
+              <a:buNone/>
+            </a:pPr>
+            <a:r>
+              <a:rPr/>
+              <a:t>With 97% power, this test has excellent ability to detect the specified effect size. Generally, </a:t>
+            </a:r>
+            <a:r>
               <a:rPr b="1"/>
-              <a:t>Confidence Interval (CI)</a:t>
-            </a:r>
-            <a:r>
-              <a:rPr/>
-              <a:t>: Shows plausible range for parameter</a:t>
-            </a:r>
-          </a:p>
-          <a:p>
-            <a:pPr lvl="0" indent="0" marL="0">
-              <a:buNone/>
-            </a:pPr>
-            <a:r>
-              <a:rPr/>
-              <a:t>When interpreting graphs:</a:t>
-            </a:r>
-          </a:p>
-          <a:p>
-            <a:pPr lvl="0"/>
-            <a:r>
-              <a:rPr/>
-              <a:t>Always check what the error bars represent</a:t>
-            </a:r>
-          </a:p>
-          <a:p>
-            <a:pPr lvl="0"/>
-            <a:r>
-              <a:rPr/>
-              <a:t>Non-overlapping 95% CI bars suggest statistically significant differences</a:t>
-            </a:r>
-          </a:p>
-          <a:p>
-            <a:pPr lvl="0"/>
-            <a:r>
-              <a:rPr/>
-              <a:t>Error bars help assess both statistical and practical significance</a:t>
-            </a:r>
-          </a:p>
-        </p:txBody>
-      </p:sp>
-      <p:pic>
-        <p:nvPicPr>
-          <p:cNvPr descr="06_01_lecture_powerpoint_files/figure-pptx/unnamed-chunk-4-1.png" id="0" name="Picture 1"/>
-          <p:cNvPicPr>
-            <a:picLocks noGrp="1" noChangeAspect="1"/>
-          </p:cNvPicPr>
-          <p:nvPr/>
-        </p:nvPicPr>
-        <p:blipFill>
-          <a:blip r:embed="rId2"/>
-          <a:stretch>
-            <a:fillRect/>
-          </a:stretch>
-        </p:blipFill>
-        <p:spPr bwMode="auto">
-          <a:xfrm>
-            <a:off x="6121400" y="1498600"/>
-            <a:ext cx="2781300" cy="2781300"/>
-          </a:xfrm>
-          <a:prstGeom prst="rect">
-            <a:avLst/>
-          </a:prstGeom>
-          <a:noFill/>
-          <a:ln w="9525">
-            <a:noFill/>
-            <a:headEnd/>
-            <a:tailEnd/>
-          </a:ln>
-        </p:spPr>
-      </p:pic>
+              <a:t>80% power is considered acceptable</a:t>
+            </a:r>
+            <a:r>
+              <a:rPr/>
+              <a:t>, so 97% indicates a very well-powered study for detecting a difference of XXg between the groups.</a:t>
+            </a:r>
+          </a:p>
+        </p:txBody>
+      </p:sp>
     </p:spTree>
   </p:cSld>
 </p:sld>
@@ -6504,7 +8153,7 @@
             </a:r>
             <a:r>
               <a:rPr/>
-              <a:t> Sampling and Pseudoreplication</a:t>
+              <a:t> Error Bars and Their Interpretation</a:t>
             </a:r>
           </a:p>
         </p:txBody>
@@ -6528,93 +8177,131 @@
               <a:buNone/>
             </a:pPr>
             <a:r>
+              <a:rPr/>
+              <a:t>Error bars are graphical representations of the variability of data that show:</a:t>
+            </a:r>
+          </a:p>
+          <a:p>
+            <a:pPr lvl="0"/>
+            <a:r>
+              <a:rPr/>
+              <a:t>The </a:t>
+            </a:r>
+            <a:r>
               <a:rPr b="1"/>
-              <a:t>Pseudoreplication</a:t>
-            </a:r>
-            <a:r>
-              <a:rPr/>
-              <a:t> occurs when measurements that are not independent are analyzed as if they were independent.</a:t>
+              <a:t>precision</a:t>
+            </a:r>
+            <a:r>
+              <a:rPr/>
+              <a:t> of a measurement</a:t>
             </a:r>
           </a:p>
           <a:p>
             <a:pPr lvl="0"/>
             <a:r>
               <a:rPr/>
-              <a:t>A critical consideration in experimental design</a:t>
+              <a:t>The </a:t>
+            </a:r>
+            <a:r>
+              <a:rPr b="1"/>
+              <a:t>uncertainty</a:t>
+            </a:r>
+            <a:r>
+              <a:rPr/>
+              <a:t> around an estimate</a:t>
             </a:r>
           </a:p>
           <a:p>
             <a:pPr lvl="0"/>
             <a:r>
               <a:rPr/>
-              <a:t>Results in underestimated standard errors and confidence intervals</a:t>
+              <a:t>A </a:t>
+            </a:r>
+            <a:r>
+              <a:rPr b="1"/>
+              <a:t>confidence interval</a:t>
+            </a:r>
+            <a:r>
+              <a:rPr/>
+              <a:t> for a parameter</a:t>
+            </a:r>
+          </a:p>
+          <a:p>
+            <a:pPr lvl="0" indent="0" marL="0">
+              <a:buNone/>
+            </a:pPr>
+            <a:r>
+              <a:rPr/>
+              <a:t>Common types of error bars:</a:t>
+            </a:r>
+          </a:p>
+          <a:p>
+            <a:pPr lvl="0" indent="-342900" marL="342900">
+              <a:buAutoNum type="arabicPeriod"/>
+            </a:pPr>
+            <a:r>
+              <a:rPr b="1"/>
+              <a:t>Standard Error (SE)</a:t>
+            </a:r>
+            <a:r>
+              <a:rPr/>
+              <a:t>: Shows precision of the mean</a:t>
+            </a:r>
+          </a:p>
+          <a:p>
+            <a:pPr lvl="0" indent="-342900" marL="342900">
+              <a:buAutoNum type="arabicPeriod"/>
+            </a:pPr>
+            <a:r>
+              <a:rPr b="1"/>
+              <a:t>Standard Deviation (SD)</a:t>
+            </a:r>
+            <a:r>
+              <a:rPr/>
+              <a:t>: Shows variability in the data</a:t>
+            </a:r>
+          </a:p>
+          <a:p>
+            <a:pPr lvl="0" indent="-342900" marL="342900">
+              <a:buAutoNum type="arabicPeriod"/>
+            </a:pPr>
+            <a:r>
+              <a:rPr b="1"/>
+              <a:t>Confidence Interval (CI)</a:t>
+            </a:r>
+            <a:r>
+              <a:rPr/>
+              <a:t>: Shows plausible range for parameter</a:t>
+            </a:r>
+          </a:p>
+          <a:p>
+            <a:pPr lvl="0" indent="0" marL="0">
+              <a:buNone/>
+            </a:pPr>
+            <a:r>
+              <a:rPr/>
+              <a:t>When interpreting graphs:</a:t>
             </a:r>
           </a:p>
           <a:p>
             <a:pPr lvl="0"/>
             <a:r>
               <a:rPr/>
-              <a:t>Leads to inflated Type I error rates (false positives)</a:t>
-            </a:r>
-          </a:p>
-          <a:p>
-            <a:pPr lvl="0" indent="0" marL="0">
-              <a:buNone/>
-            </a:pPr>
-            <a:r>
-              <a:rPr b="1"/>
-              <a:t>Examples of pseudoreplication:</a:t>
+              <a:t>Always check what the error bars represent</a:t>
             </a:r>
           </a:p>
           <a:p>
             <a:pPr lvl="0"/>
             <a:r>
               <a:rPr/>
-              <a:t>Measuring the same individual multiple times</a:t>
+              <a:t>Non-overlapping 95% CI bars suggest statistically significant differences</a:t>
             </a:r>
           </a:p>
           <a:p>
             <a:pPr lvl="0"/>
             <a:r>
               <a:rPr/>
-              <a:t>Treating multiple fish from the same tank as independent</a:t>
-            </a:r>
-          </a:p>
-          <a:p>
-            <a:pPr lvl="0"/>
-            <a:r>
-              <a:rPr/>
-              <a:t>Using multiple data points from a single site</a:t>
-            </a:r>
-          </a:p>
-          <a:p>
-            <a:pPr lvl="0" indent="0" marL="0">
-              <a:buNone/>
-            </a:pPr>
-            <a:r>
-              <a:rPr b="1"/>
-              <a:t>How to avoid pseudoreplication:</a:t>
-            </a:r>
-          </a:p>
-          <a:p>
-            <a:pPr lvl="0"/>
-            <a:r>
-              <a:rPr/>
-              <a:t>Identify the true experimental unit</a:t>
-            </a:r>
-          </a:p>
-          <a:p>
-            <a:pPr lvl="0"/>
-            <a:r>
-              <a:rPr/>
-              <a:t>Use appropriate statistical techniques (e.g., mixed models)</a:t>
-            </a:r>
-          </a:p>
-          <a:p>
-            <a:pPr lvl="0"/>
-            <a:r>
-              <a:rPr/>
-              <a:t>Be clear about the level of replication</a:t>
+              <a:t>Error bars help assess both statistical and practical significance</a:t>
             </a:r>
           </a:p>
         </p:txBody>
@@ -6703,7 +8390,7 @@
             </a:r>
             <a:r>
               <a:rPr/>
-              <a:t> Practical Applications in Fish Biology</a:t>
+              <a:t> Sampling and Pseudoreplication</a:t>
             </a:r>
           </a:p>
         </p:txBody>
@@ -6727,96 +8414,93 @@
               <a:buNone/>
             </a:pPr>
             <a:r>
-              <a:rPr/>
-              <a:t>The statistical concepts we’ve covered today are essential for fisheries biologists and ecologists:</a:t>
+              <a:rPr b="1"/>
+              <a:t>Pseudoreplication</a:t>
+            </a:r>
+            <a:r>
+              <a:rPr/>
+              <a:t> occurs when measurements that are not independent are analyzed as if they were independent.</a:t>
             </a:r>
           </a:p>
           <a:p>
             <a:pPr lvl="0"/>
             <a:r>
+              <a:rPr/>
+              <a:t>A critical consideration in experimental design</a:t>
+            </a:r>
+          </a:p>
+          <a:p>
+            <a:pPr lvl="0"/>
+            <a:r>
+              <a:rPr/>
+              <a:t>Results in underestimated standard errors and confidence intervals</a:t>
+            </a:r>
+          </a:p>
+          <a:p>
+            <a:pPr lvl="0"/>
+            <a:r>
+              <a:rPr/>
+              <a:t>Leads to inflated Type I error rates (false positives)</a:t>
+            </a:r>
+          </a:p>
+          <a:p>
+            <a:pPr lvl="0" indent="0" marL="0">
+              <a:buNone/>
+            </a:pPr>
+            <a:r>
               <a:rPr b="1"/>
-              <a:t>Standard error</a:t>
-            </a:r>
-            <a:r>
-              <a:rPr/>
-              <a:t> quantifies uncertainty in growth rate estimates</a:t>
+              <a:t>Examples of pseudoreplication:</a:t>
             </a:r>
           </a:p>
           <a:p>
             <a:pPr lvl="0"/>
             <a:r>
+              <a:rPr/>
+              <a:t>Measuring the same individual multiple times</a:t>
+            </a:r>
+          </a:p>
+          <a:p>
+            <a:pPr lvl="0"/>
+            <a:r>
+              <a:rPr/>
+              <a:t>Treating multiple fish from the same tank as independent</a:t>
+            </a:r>
+          </a:p>
+          <a:p>
+            <a:pPr lvl="0"/>
+            <a:r>
+              <a:rPr/>
+              <a:t>Using multiple data points from a single site</a:t>
+            </a:r>
+          </a:p>
+          <a:p>
+            <a:pPr lvl="0" indent="0" marL="0">
+              <a:buNone/>
+            </a:pPr>
+            <a:r>
               <a:rPr b="1"/>
-              <a:t>Confidence intervals</a:t>
-            </a:r>
-            <a:r>
-              <a:rPr/>
-              <a:t> provide plausible ranges for population parameters</a:t>
+              <a:t>How to avoid pseudoreplication:</a:t>
             </a:r>
           </a:p>
           <a:p>
             <a:pPr lvl="0"/>
             <a:r>
-              <a:rPr b="1"/>
-              <a:t>Hypothesis testing</a:t>
-            </a:r>
-            <a:r>
-              <a:rPr/>
-              <a:t> evaluates effects of management practices</a:t>
+              <a:rPr/>
+              <a:t>Identify the true experimental unit</a:t>
             </a:r>
           </a:p>
           <a:p>
             <a:pPr lvl="0"/>
             <a:r>
-              <a:rPr b="1"/>
-              <a:t>P-values</a:t>
-            </a:r>
-            <a:r>
-              <a:rPr/>
-              <a:t> determine significance of environmental impacts</a:t>
-            </a:r>
-          </a:p>
-          <a:p>
-            <a:pPr lvl="0" indent="0" marL="0">
-              <a:buNone/>
-            </a:pPr>
-            <a:r>
-              <a:rPr b="1"/>
-              <a:t>Real-world applications:</a:t>
+              <a:rPr/>
+              <a:t>Use appropriate statistical techniques (e.g., mixed models)</a:t>
             </a:r>
           </a:p>
           <a:p>
             <a:pPr lvl="0"/>
             <a:r>
               <a:rPr/>
-              <a:t>Assessing population health and structure</a:t>
-            </a:r>
-          </a:p>
-          <a:p>
-            <a:pPr lvl="0"/>
-            <a:r>
-              <a:rPr/>
-              <a:t>Evaluating effectiveness of fishing regulations</a:t>
-            </a:r>
-          </a:p>
-          <a:p>
-            <a:pPr lvl="0"/>
-            <a:r>
-              <a:rPr/>
-              <a:t>Quantifying relationships between fish size and habitat variables</a:t>
-            </a:r>
-          </a:p>
-          <a:p>
-            <a:pPr lvl="0"/>
-            <a:r>
-              <a:rPr/>
-              <a:t>Predicting impacts of climate change on fish populations</a:t>
-            </a:r>
-          </a:p>
-          <a:p>
-            <a:pPr lvl="0"/>
-            <a:r>
-              <a:rPr/>
-              <a:t>Designing effective conservation strategies</a:t>
+              <a:t>Be clear about the level of replication</a:t>
             </a:r>
           </a:p>
         </p:txBody>
@@ -6886,6 +8570,208 @@
         <p:spPr>
           <a:xfrm>
             <a:off x="0" y="0"/>
+            <a:ext cx="9144000" cy="602780"/>
+          </a:xfrm>
+          <a:solidFill>
+            <a:srgbClr val="70121D"/>
+          </a:solidFill>
+        </p:spPr>
+        <p:txBody>
+          <a:bodyPr/>
+          <a:lstStyle/>
+          <a:p>
+            <a:pPr lvl="0" indent="0" marL="0">
+              <a:buNone/>
+            </a:pPr>
+            <a:r>
+              <a:rPr b="1"/>
+              <a:t>Lecture 6:</a:t>
+            </a:r>
+            <a:r>
+              <a:rPr/>
+              <a:t> Practical Applications in Fish Biology</a:t>
+            </a:r>
+          </a:p>
+        </p:txBody>
+      </p:sp>
+      <p:sp>
+        <p:nvSpPr>
+          <p:cNvPr id="3" name="Content Placeholder 2"/>
+          <p:cNvSpPr>
+            <a:spLocks noGrp="1"/>
+          </p:cNvSpPr>
+          <p:nvPr>
+            <p:ph idx="1" sz="half"/>
+          </p:nvPr>
+        </p:nvSpPr>
+        <p:spPr/>
+        <p:txBody>
+          <a:bodyPr/>
+          <a:lstStyle/>
+          <a:p>
+            <a:pPr lvl="0" indent="0" marL="0">
+              <a:buNone/>
+            </a:pPr>
+            <a:r>
+              <a:rPr/>
+              <a:t>The statistical concepts we’ve covered today are essential for fisheries biologists and ecologists:</a:t>
+            </a:r>
+          </a:p>
+          <a:p>
+            <a:pPr lvl="0"/>
+            <a:r>
+              <a:rPr b="1"/>
+              <a:t>Standard error</a:t>
+            </a:r>
+            <a:r>
+              <a:rPr/>
+              <a:t> quantifies uncertainty in growth rate estimates</a:t>
+            </a:r>
+          </a:p>
+          <a:p>
+            <a:pPr lvl="0"/>
+            <a:r>
+              <a:rPr b="1"/>
+              <a:t>Confidence intervals</a:t>
+            </a:r>
+            <a:r>
+              <a:rPr/>
+              <a:t> provide plausible ranges for population parameters</a:t>
+            </a:r>
+          </a:p>
+          <a:p>
+            <a:pPr lvl="0"/>
+            <a:r>
+              <a:rPr b="1"/>
+              <a:t>Hypothesis testing</a:t>
+            </a:r>
+            <a:r>
+              <a:rPr/>
+              <a:t> evaluates effects of management practices</a:t>
+            </a:r>
+          </a:p>
+          <a:p>
+            <a:pPr lvl="0"/>
+            <a:r>
+              <a:rPr b="1"/>
+              <a:t>P-values</a:t>
+            </a:r>
+            <a:r>
+              <a:rPr/>
+              <a:t> determine significance of environmental impacts</a:t>
+            </a:r>
+          </a:p>
+          <a:p>
+            <a:pPr lvl="0" indent="0" marL="0">
+              <a:buNone/>
+            </a:pPr>
+            <a:r>
+              <a:rPr b="1"/>
+              <a:t>Real-world applications:</a:t>
+            </a:r>
+          </a:p>
+          <a:p>
+            <a:pPr lvl="0"/>
+            <a:r>
+              <a:rPr/>
+              <a:t>Assessing population health and structure</a:t>
+            </a:r>
+          </a:p>
+          <a:p>
+            <a:pPr lvl="0"/>
+            <a:r>
+              <a:rPr/>
+              <a:t>Evaluating effectiveness of fishing regulations</a:t>
+            </a:r>
+          </a:p>
+          <a:p>
+            <a:pPr lvl="0"/>
+            <a:r>
+              <a:rPr/>
+              <a:t>Quantifying relationships between fish size and habitat variables</a:t>
+            </a:r>
+          </a:p>
+          <a:p>
+            <a:pPr lvl="0"/>
+            <a:r>
+              <a:rPr/>
+              <a:t>Predicting impacts of climate change on fish populations</a:t>
+            </a:r>
+          </a:p>
+          <a:p>
+            <a:pPr lvl="0"/>
+            <a:r>
+              <a:rPr/>
+              <a:t>Designing effective conservation strategies</a:t>
+            </a:r>
+          </a:p>
+        </p:txBody>
+      </p:sp>
+      <p:pic>
+        <p:nvPicPr>
+          <p:cNvPr descr="06_01_lecture_powerpoint_files/figure-pptx/unnamed-chunk-7-1.png" id="0" name="Picture 1"/>
+          <p:cNvPicPr>
+            <a:picLocks noGrp="1" noChangeAspect="1"/>
+          </p:cNvPicPr>
+          <p:nvPr/>
+        </p:nvPicPr>
+        <p:blipFill>
+          <a:blip r:embed="rId2"/>
+          <a:stretch>
+            <a:fillRect/>
+          </a:stretch>
+        </p:blipFill>
+        <p:spPr bwMode="auto">
+          <a:xfrm>
+            <a:off x="6121400" y="1498600"/>
+            <a:ext cx="2781300" cy="2781300"/>
+          </a:xfrm>
+          <a:prstGeom prst="rect">
+            <a:avLst/>
+          </a:prstGeom>
+          <a:noFill/>
+          <a:ln w="9525">
+            <a:noFill/>
+            <a:headEnd/>
+            <a:tailEnd/>
+          </a:ln>
+        </p:spPr>
+      </p:pic>
+    </p:spTree>
+  </p:cSld>
+</p:sld>
+</file>
+
+<file path=ppt/slides/slide24.xml><?xml version="1.0" encoding="utf-8"?>
+<p:sld xmlns:a="http://schemas.openxmlformats.org/drawingml/2006/main" xmlns:r="http://schemas.openxmlformats.org/officeDocument/2006/relationships" xmlns:p="http://schemas.openxmlformats.org/presentationml/2006/main">
+  <p:cSld>
+    <p:spTree>
+      <p:nvGrpSpPr>
+        <p:cNvPr id="1" name=""/>
+        <p:cNvGrpSpPr/>
+        <p:nvPr/>
+      </p:nvGrpSpPr>
+      <p:grpSpPr>
+        <a:xfrm>
+          <a:off x="0" y="0"/>
+          <a:ext cx="0" cy="0"/>
+          <a:chOff x="0" y="0"/>
+          <a:chExt cx="0" cy="0"/>
+        </a:xfrm>
+      </p:grpSpPr>
+      <p:sp>
+        <p:nvSpPr>
+          <p:cNvPr id="2" name="Title 1"/>
+          <p:cNvSpPr>
+            <a:spLocks noGrp="1"/>
+          </p:cNvSpPr>
+          <p:nvPr>
+            <p:ph type="title"/>
+          </p:nvPr>
+        </p:nvSpPr>
+        <p:spPr>
+          <a:xfrm>
+            <a:off x="0" y="0"/>
             <a:ext cx="9144000" cy="582780"/>
           </a:xfrm>
         </p:spPr>
@@ -8150,14 +10036,22 @@
             <a:pPr lvl="0"/>
             <a:r>
               <a:rPr/>
-              <a:t>p = 0.3 means that if I repeated the study 100 times, I would get this (or more extreme) result due to chance 30 times</a:t>
+              <a:t>p = 0.3 means that if I repeated the study 100 times, I would get this (or more extreme) result due to chance </a:t>
+            </a:r>
+            <a:r>
+              <a:rPr b="1"/>
+              <a:t>30 times</a:t>
             </a:r>
           </a:p>
           <a:p>
             <a:pPr lvl="0"/>
             <a:r>
               <a:rPr/>
-              <a:t>p = 0.03 means that if I repeated the study 100 times, I would get this (or more extreme) result due to chance 3 times</a:t>
+              <a:t>p = 0.03 means that if I repeated the study 100 times, I would get this (or more extreme) result due to chance </a:t>
+            </a:r>
+            <a:r>
+              <a:rPr b="1"/>
+              <a:t>3 times</a:t>
             </a:r>
           </a:p>
           <a:p>

</xml_diff>

<commit_message>
fixed 6 need to add power
</commit_message>
<xml_diff>
--- a/docs/ecostats_lectures/lecture_06/06_01_lecture_powerpoint.pptx
+++ b/docs/ecostats_lectures/lecture_06/06_01_lecture_powerpoint.pptx
@@ -7859,11 +7859,8 @@
         <p:spPr>
           <a:xfrm>
             <a:off x="0" y="0"/>
-            <a:ext cx="9144000" cy="602780"/>
+            <a:ext cx="9144000" cy="582780"/>
           </a:xfrm>
-          <a:solidFill>
-            <a:srgbClr val="70121D"/>
-          </a:solidFill>
         </p:spPr>
         <p:txBody>
           <a:bodyPr/>
@@ -7886,7 +7883,7 @@
             <a:spLocks noGrp="1"/>
           </p:cNvSpPr>
           <p:nvPr>
-            <p:ph idx="1" sz="half"/>
+            <p:ph idx="1"/>
           </p:nvPr>
         </p:nvSpPr>
         <p:spPr/>
@@ -7937,38 +7934,13 @@
               <a:t>Two sample T</a:t>
             </a:r>
           </a:p>
-        </p:txBody>
-      </p:sp>
-      <p:pic>
-        <p:nvPicPr>
-          <p:cNvPr descr="images/clipboard-536528302.png" id="0" name="Picture 1"/>
-          <p:cNvPicPr>
-            <a:picLocks noGrp="1" noChangeAspect="1"/>
-          </p:cNvPicPr>
-          <p:nvPr/>
-        </p:nvPicPr>
-        <p:blipFill>
-          <a:blip r:embed="rId2"/>
-          <a:stretch>
-            <a:fillRect/>
-          </a:stretch>
-        </p:blipFill>
-        <p:spPr bwMode="auto">
-          <a:xfrm>
-            <a:off x="6121400" y="889000"/>
-            <a:ext cx="2781300" cy="4013200"/>
-          </a:xfrm>
-          <a:prstGeom prst="rect">
-            <a:avLst/>
-          </a:prstGeom>
-          <a:noFill/>
-          <a:ln w="9525">
-            <a:noFill/>
-            <a:headEnd/>
-            <a:tailEnd/>
-          </a:ln>
-        </p:spPr>
-      </p:pic>
+          <a:p>
+            <a:pPr lvl="0" indent="0" marL="0">
+              <a:buNone/>
+            </a:pPr>
+          </a:p>
+        </p:txBody>
+      </p:sp>
     </p:spTree>
   </p:cSld>
 </p:sld>

</xml_diff>